<commit_message>
Split board-review Q&A: question slide, then answer reveal (135 questions across 34 decks); update slide counts to 1045
</commit_message>
<xml_diff>
--- a/decks/Chem_01_Analytic-Techniques-and-Error.pptx
+++ b/decks/Chem_01_Analytic-Techniques-and-Error.pptx
@@ -27,9 +27,13 @@
     <p:sldId id="275" r:id="rId21"/>
     <p:sldId id="276" r:id="rId22"/>
     <p:sldId id="277" r:id="rId23"/>
+    <p:sldId id="286" r:id="rId37"/>
     <p:sldId id="278" r:id="rId24"/>
+    <p:sldId id="285" r:id="rId36"/>
     <p:sldId id="279" r:id="rId25"/>
+    <p:sldId id="284" r:id="rId35"/>
     <p:sldId id="280" r:id="rId26"/>
+    <p:sldId id="283" r:id="rId34"/>
     <p:sldId id="281" r:id="rId27"/>
     <p:sldId id="282" r:id="rId28"/>
   </p:sldIdLst>
@@ -3210,6 +3214,10 @@
           </a:solidFill>
           <a:ln/>
         </p:spPr>
+        <p:txBody>
+          <a:bodyPr/>
+          <a:p/>
+        </p:txBody>
       </p:sp>
       <p:sp>
         <p:nvSpPr>
@@ -3232,6 +3240,10 @@
           </a:solidFill>
           <a:ln/>
         </p:spPr>
+        <p:txBody>
+          <a:bodyPr/>
+          <a:p/>
+        </p:txBody>
       </p:sp>
       <p:sp>
         <p:nvSpPr>
@@ -3254,6 +3266,10 @@
           </a:solidFill>
           <a:ln/>
         </p:spPr>
+        <p:txBody>
+          <a:bodyPr/>
+          <a:p/>
+        </p:txBody>
       </p:sp>
       <p:sp>
         <p:nvSpPr>
@@ -3276,6 +3292,10 @@
           </a:solidFill>
           <a:ln/>
         </p:spPr>
+        <p:txBody>
+          <a:bodyPr/>
+          <a:p/>
+        </p:txBody>
       </p:sp>
       <p:sp>
         <p:nvSpPr>
@@ -3607,6 +3627,10 @@
           </a:solidFill>
           <a:ln/>
         </p:spPr>
+        <p:txBody>
+          <a:bodyPr/>
+          <a:p/>
+        </p:txBody>
       </p:sp>
       <p:sp>
         <p:nvSpPr>
@@ -3629,6 +3653,10 @@
           </a:solidFill>
           <a:ln/>
         </p:spPr>
+        <p:txBody>
+          <a:bodyPr/>
+          <a:p/>
+        </p:txBody>
       </p:sp>
       <p:sp>
         <p:nvSpPr>
@@ -3885,6 +3913,10 @@
             </a:outerShdw>
           </a:effectLst>
         </p:spPr>
+        <p:txBody>
+          <a:bodyPr/>
+          <a:p/>
+        </p:txBody>
       </p:sp>
       <p:sp>
         <p:nvSpPr>
@@ -4059,6 +4091,10 @@
             </a:outerShdw>
           </a:effectLst>
         </p:spPr>
+        <p:txBody>
+          <a:bodyPr/>
+          <a:p/>
+        </p:txBody>
       </p:sp>
       <p:sp>
         <p:nvSpPr>
@@ -5770,6 +5806,10 @@
             </a:outerShdw>
           </a:effectLst>
         </p:spPr>
+        <p:txBody>
+          <a:bodyPr/>
+          <a:p/>
+        </p:txBody>
       </p:sp>
       <p:sp>
         <p:nvSpPr>
@@ -5850,6 +5890,10 @@
             <a:tailEnd type="triangle"/>
           </a:ln>
         </p:spPr>
+        <p:txBody>
+          <a:bodyPr/>
+          <a:p/>
+        </p:txBody>
       </p:sp>
       <p:sp>
         <p:nvSpPr>
@@ -5884,6 +5928,10 @@
             </a:outerShdw>
           </a:effectLst>
         </p:spPr>
+        <p:txBody>
+          <a:bodyPr/>
+          <a:p/>
+        </p:txBody>
       </p:sp>
       <p:sp>
         <p:nvSpPr>
@@ -5964,6 +6012,10 @@
             <a:tailEnd type="triangle"/>
           </a:ln>
         </p:spPr>
+        <p:txBody>
+          <a:bodyPr/>
+          <a:p/>
+        </p:txBody>
       </p:sp>
       <p:sp>
         <p:nvSpPr>
@@ -5998,6 +6050,10 @@
             </a:outerShdw>
           </a:effectLst>
         </p:spPr>
+        <p:txBody>
+          <a:bodyPr/>
+          <a:p/>
+        </p:txBody>
       </p:sp>
       <p:sp>
         <p:nvSpPr>
@@ -6083,6 +6139,10 @@
             </a:outerShdw>
           </a:effectLst>
         </p:spPr>
+        <p:txBody>
+          <a:bodyPr/>
+          <a:p/>
+        </p:txBody>
       </p:sp>
       <p:sp>
         <p:nvSpPr>
@@ -6434,6 +6494,10 @@
             </a:outerShdw>
           </a:effectLst>
         </p:spPr>
+        <p:txBody>
+          <a:bodyPr/>
+          <a:p/>
+        </p:txBody>
       </p:sp>
       <p:sp>
         <p:nvSpPr>
@@ -6608,6 +6672,10 @@
             </a:outerShdw>
           </a:effectLst>
         </p:spPr>
+        <p:txBody>
+          <a:bodyPr/>
+          <a:p/>
+        </p:txBody>
       </p:sp>
       <p:sp>
         <p:nvSpPr>
@@ -6913,6 +6981,10 @@
           </a:solidFill>
           <a:ln/>
         </p:spPr>
+        <p:txBody>
+          <a:bodyPr/>
+          <a:p/>
+        </p:txBody>
       </p:sp>
       <p:sp>
         <p:nvSpPr>
@@ -6935,6 +7007,10 @@
           </a:solidFill>
           <a:ln/>
         </p:spPr>
+        <p:txBody>
+          <a:bodyPr/>
+          <a:p/>
+        </p:txBody>
       </p:sp>
       <p:sp>
         <p:nvSpPr>
@@ -7191,6 +7267,10 @@
             </a:outerShdw>
           </a:effectLst>
         </p:spPr>
+        <p:txBody>
+          <a:bodyPr/>
+          <a:p/>
+        </p:txBody>
       </p:sp>
       <p:sp>
         <p:nvSpPr>
@@ -7301,6 +7381,10 @@
             </a:outerShdw>
           </a:effectLst>
         </p:spPr>
+        <p:txBody>
+          <a:bodyPr/>
+          <a:p/>
+        </p:txBody>
       </p:sp>
       <p:sp>
         <p:nvSpPr>
@@ -7730,6 +7814,10 @@
             </a:outerShdw>
           </a:effectLst>
         </p:spPr>
+        <p:txBody>
+          <a:bodyPr/>
+          <a:p/>
+        </p:txBody>
       </p:sp>
       <p:sp>
         <p:nvSpPr>
@@ -8056,6 +8144,10 @@
             </a:outerShdw>
           </a:effectLst>
         </p:spPr>
+        <p:txBody>
+          <a:bodyPr/>
+          <a:p/>
+        </p:txBody>
       </p:sp>
       <p:sp>
         <p:nvSpPr>
@@ -8166,6 +8258,10 @@
             </a:outerShdw>
           </a:effectLst>
         </p:spPr>
+        <p:txBody>
+          <a:bodyPr/>
+          <a:p/>
+        </p:txBody>
       </p:sp>
       <p:sp>
         <p:nvSpPr>
@@ -8595,6 +8691,10 @@
             </a:outerShdw>
           </a:effectLst>
         </p:spPr>
+        <p:txBody>
+          <a:bodyPr/>
+          <a:p/>
+        </p:txBody>
       </p:sp>
       <p:sp>
         <p:nvSpPr>
@@ -8921,6 +9021,10 @@
             </a:outerShdw>
           </a:effectLst>
         </p:spPr>
+        <p:txBody>
+          <a:bodyPr/>
+          <a:p/>
+        </p:txBody>
       </p:sp>
       <p:sp>
         <p:nvSpPr>
@@ -9028,6 +9132,10 @@
             </a:outerShdw>
           </a:effectLst>
         </p:spPr>
+        <p:txBody>
+          <a:bodyPr/>
+          <a:p/>
+        </p:txBody>
       </p:sp>
       <p:sp>
         <p:nvSpPr>
@@ -9135,6 +9243,10 @@
             </a:outerShdw>
           </a:effectLst>
         </p:spPr>
+        <p:txBody>
+          <a:bodyPr/>
+          <a:p/>
+        </p:txBody>
       </p:sp>
       <p:sp>
         <p:nvSpPr>
@@ -9242,6 +9354,10 @@
             </a:outerShdw>
           </a:effectLst>
         </p:spPr>
+        <p:txBody>
+          <a:bodyPr/>
+          <a:p/>
+        </p:txBody>
       </p:sp>
       <p:sp>
         <p:nvSpPr>
@@ -9572,6 +9688,10 @@
             </a:outerShdw>
           </a:effectLst>
         </p:spPr>
+        <p:txBody>
+          <a:bodyPr/>
+          <a:p/>
+        </p:txBody>
       </p:sp>
       <p:sp>
         <p:nvSpPr>
@@ -9682,6 +9802,10 @@
             </a:outerShdw>
           </a:effectLst>
         </p:spPr>
+        <p:txBody>
+          <a:bodyPr/>
+          <a:p/>
+        </p:txBody>
       </p:sp>
       <p:sp>
         <p:nvSpPr>
@@ -10111,6 +10235,10 @@
             </a:outerShdw>
           </a:effectLst>
         </p:spPr>
+        <p:txBody>
+          <a:bodyPr/>
+          <a:p/>
+        </p:txBody>
       </p:sp>
       <p:sp>
         <p:nvSpPr>
@@ -10499,9 +10627,9 @@
               <a:buNone/>
             </a:pPr>
             <a:r>
-              <a:rPr lang="en-US" sz="1350" b="1" dirty="0">
-                <a:solidFill>
-                  <a:srgbClr val="0D4A92"/>
+              <a:rPr lang="en-US" sz="1350" b="0" dirty="0">
+                <a:solidFill>
+                  <a:srgbClr val="33444F"/>
                 </a:solidFill>
                 <a:latin typeface="Calibri" pitchFamily="34" charset="0"/>
                 <a:ea typeface="Calibri" pitchFamily="34" charset="-122"/>
@@ -10570,130 +10698,6 @@
               <a:t>E. Repeat without changes</a:t>
             </a:r>
             <a:endParaRPr lang="en-US" sz="1350" dirty="0"/>
-          </a:p>
-        </p:txBody>
-      </p:sp>
-      <p:sp>
-        <p:nvSpPr>
-          <p:cNvPr id="6" name="Shape 4"/>
-          <p:cNvSpPr/>
-          <p:nvPr/>
-        </p:nvSpPr>
-        <p:spPr>
-          <a:xfrm>
-            <a:off x="7201632" y="2395728"/>
-            <a:ext cx="4423136" cy="3246120"/>
-          </a:xfrm>
-          <a:prstGeom prst="roundRect">
-            <a:avLst>
-              <a:gd name="adj" fmla="val 2535"/>
-            </a:avLst>
-          </a:prstGeom>
-          <a:solidFill>
-            <a:srgbClr val="E7EFFA"/>
-          </a:solidFill>
-          <a:ln/>
-          <a:effectLst>
-            <a:outerShdw sx="100000" sy="100000" kx="0" ky="0" algn="bl" rotWithShape="0" blurRad="88900" dist="25400" dir="5400000">
-              <a:srgbClr val="22303C">
-                <a:alpha val="12000"/>
-              </a:srgbClr>
-            </a:outerShdw>
-          </a:effectLst>
-        </p:spPr>
-      </p:sp>
-      <p:sp>
-        <p:nvSpPr>
-          <p:cNvPr id="7" name="Text 5"/>
-          <p:cNvSpPr/>
-          <p:nvPr/>
-        </p:nvSpPr>
-        <p:spPr>
-          <a:xfrm>
-            <a:off x="7439376" y="2578608"/>
-            <a:ext cx="3965936" cy="457200"/>
-          </a:xfrm>
-          <a:prstGeom prst="rect">
-            <a:avLst/>
-          </a:prstGeom>
-          <a:noFill/>
-          <a:ln/>
-        </p:spPr>
-        <p:txBody>
-          <a:bodyPr wrap="square" lIns="0" tIns="0" rIns="0" bIns="0" rtlCol="0" anchor="ctr"/>
-          <a:lstStyle/>
-          <a:p>
-            <a:pPr indent="0" marL="0">
-              <a:buNone/>
-            </a:pPr>
-            <a:r>
-              <a:rPr lang="en-US" sz="1500" b="1" dirty="0">
-                <a:solidFill>
-                  <a:srgbClr val="1565C0"/>
-                </a:solidFill>
-                <a:latin typeface="Calibri" pitchFamily="34" charset="0"/>
-                <a:ea typeface="Calibri" pitchFamily="34" charset="-122"/>
-                <a:cs typeface="Calibri" pitchFamily="34" charset="-120"/>
-              </a:rPr>
-              <a:t>ANSWER  </a:t>
-            </a:r>
-            <a:pPr indent="0" marL="0">
-              <a:buNone/>
-            </a:pPr>
-            <a:r>
-              <a:rPr lang="en-US" sz="1500" b="1" dirty="0">
-                <a:solidFill>
-                  <a:srgbClr val="1B2A38"/>
-                </a:solidFill>
-                <a:latin typeface="Calibri" pitchFamily="34" charset="0"/>
-                <a:ea typeface="Calibri" pitchFamily="34" charset="-122"/>
-                <a:cs typeface="Calibri" pitchFamily="34" charset="-120"/>
-              </a:rPr>
-              <a:t>B — Dilute and re-assay (hook effect)</a:t>
-            </a:r>
-            <a:endParaRPr lang="en-US" sz="1500" dirty="0"/>
-          </a:p>
-        </p:txBody>
-      </p:sp>
-      <p:sp>
-        <p:nvSpPr>
-          <p:cNvPr id="8" name="Text 6"/>
-          <p:cNvSpPr/>
-          <p:nvPr/>
-        </p:nvSpPr>
-        <p:spPr>
-          <a:xfrm>
-            <a:off x="7439376" y="3127248"/>
-            <a:ext cx="3947648" cy="2377440"/>
-          </a:xfrm>
-          <a:prstGeom prst="rect">
-            <a:avLst/>
-          </a:prstGeom>
-          <a:noFill/>
-          <a:ln/>
-        </p:spPr>
-        <p:txBody>
-          <a:bodyPr wrap="square" lIns="0" tIns="0" rIns="0" bIns="0" rtlCol="0" anchor="t"/>
-          <a:lstStyle/>
-          <a:p>
-            <a:pPr algn="l" indent="0" marL="0">
-              <a:lnSpc>
-                <a:spcPct val="108000"/>
-              </a:lnSpc>
-              <a:buNone/>
-            </a:pPr>
-            <a:r>
-              <a:rPr lang="en-US" sz="1250" dirty="0">
-                <a:solidFill>
-                  <a:srgbClr val="33444F"/>
-                </a:solidFill>
-                <a:latin typeface="Calibri" pitchFamily="34" charset="0"/>
-                <a:ea typeface="Calibri" pitchFamily="34" charset="-122"/>
-                <a:cs typeface="Calibri" pitchFamily="34" charset="-120"/>
-              </a:rPr>
-              <a:t>Extremely high analyte saturates a sandwich assay’s antibodies and lowers signal (hook). Dilution relieves saturation and yields the true value.</a:t>
-            </a:r>
-            <a:endParaRPr lang="en-US" sz="1250" dirty="0"/>
           </a:p>
         </p:txBody>
       </p:sp>
@@ -11003,9 +11007,9 @@
               <a:buNone/>
             </a:pPr>
             <a:r>
-              <a:rPr lang="en-US" sz="1350" b="1" dirty="0">
-                <a:solidFill>
-                  <a:srgbClr val="0D4A92"/>
+              <a:rPr lang="en-US" sz="1350" b="0" dirty="0">
+                <a:solidFill>
+                  <a:srgbClr val="33444F"/>
                 </a:solidFill>
                 <a:latin typeface="Calibri" pitchFamily="34" charset="0"/>
                 <a:ea typeface="Calibri" pitchFamily="34" charset="-122"/>
@@ -11074,130 +11078,6 @@
               <a:t>E. TSH, free T4</a:t>
             </a:r>
             <a:endParaRPr lang="en-US" sz="1350" dirty="0"/>
-          </a:p>
-        </p:txBody>
-      </p:sp>
-      <p:sp>
-        <p:nvSpPr>
-          <p:cNvPr id="6" name="Shape 4"/>
-          <p:cNvSpPr/>
-          <p:nvPr/>
-        </p:nvSpPr>
-        <p:spPr>
-          <a:xfrm>
-            <a:off x="7201632" y="2395728"/>
-            <a:ext cx="4423136" cy="3246120"/>
-          </a:xfrm>
-          <a:prstGeom prst="roundRect">
-            <a:avLst>
-              <a:gd name="adj" fmla="val 2535"/>
-            </a:avLst>
-          </a:prstGeom>
-          <a:solidFill>
-            <a:srgbClr val="E7EFFA"/>
-          </a:solidFill>
-          <a:ln/>
-          <a:effectLst>
-            <a:outerShdw sx="100000" sy="100000" kx="0" ky="0" algn="bl" rotWithShape="0" blurRad="88900" dist="25400" dir="5400000">
-              <a:srgbClr val="22303C">
-                <a:alpha val="12000"/>
-              </a:srgbClr>
-            </a:outerShdw>
-          </a:effectLst>
-        </p:spPr>
-      </p:sp>
-      <p:sp>
-        <p:nvSpPr>
-          <p:cNvPr id="7" name="Text 5"/>
-          <p:cNvSpPr/>
-          <p:nvPr/>
-        </p:nvSpPr>
-        <p:spPr>
-          <a:xfrm>
-            <a:off x="7439376" y="2578608"/>
-            <a:ext cx="3965936" cy="457200"/>
-          </a:xfrm>
-          <a:prstGeom prst="rect">
-            <a:avLst/>
-          </a:prstGeom>
-          <a:noFill/>
-          <a:ln/>
-        </p:spPr>
-        <p:txBody>
-          <a:bodyPr wrap="square" lIns="0" tIns="0" rIns="0" bIns="0" rtlCol="0" anchor="ctr"/>
-          <a:lstStyle/>
-          <a:p>
-            <a:pPr indent="0" marL="0">
-              <a:buNone/>
-            </a:pPr>
-            <a:r>
-              <a:rPr lang="en-US" sz="1500" b="1" dirty="0">
-                <a:solidFill>
-                  <a:srgbClr val="1565C0"/>
-                </a:solidFill>
-                <a:latin typeface="Calibri" pitchFamily="34" charset="0"/>
-                <a:ea typeface="Calibri" pitchFamily="34" charset="-122"/>
-                <a:cs typeface="Calibri" pitchFamily="34" charset="-120"/>
-              </a:rPr>
-              <a:t>ANSWER  </a:t>
-            </a:r>
-            <a:pPr indent="0" marL="0">
-              <a:buNone/>
-            </a:pPr>
-            <a:r>
-              <a:rPr lang="en-US" sz="1500" b="1" dirty="0">
-                <a:solidFill>
-                  <a:srgbClr val="1B2A38"/>
-                </a:solidFill>
-                <a:latin typeface="Calibri" pitchFamily="34" charset="0"/>
-                <a:ea typeface="Calibri" pitchFamily="34" charset="-122"/>
-                <a:cs typeface="Calibri" pitchFamily="34" charset="-120"/>
-              </a:rPr>
-              <a:t>B — Potassium, LDH, AST, phosphate</a:t>
-            </a:r>
-            <a:endParaRPr lang="en-US" sz="1500" dirty="0"/>
-          </a:p>
-        </p:txBody>
-      </p:sp>
-      <p:sp>
-        <p:nvSpPr>
-          <p:cNvPr id="8" name="Text 6"/>
-          <p:cNvSpPr/>
-          <p:nvPr/>
-        </p:nvSpPr>
-        <p:spPr>
-          <a:xfrm>
-            <a:off x="7439376" y="3127248"/>
-            <a:ext cx="3947648" cy="2377440"/>
-          </a:xfrm>
-          <a:prstGeom prst="rect">
-            <a:avLst/>
-          </a:prstGeom>
-          <a:noFill/>
-          <a:ln/>
-        </p:spPr>
-        <p:txBody>
-          <a:bodyPr wrap="square" lIns="0" tIns="0" rIns="0" bIns="0" rtlCol="0" anchor="t"/>
-          <a:lstStyle/>
-          <a:p>
-            <a:pPr algn="l" indent="0" marL="0">
-              <a:lnSpc>
-                <a:spcPct val="108000"/>
-              </a:lnSpc>
-              <a:buNone/>
-            </a:pPr>
-            <a:r>
-              <a:rPr lang="en-US" sz="1250" dirty="0">
-                <a:solidFill>
-                  <a:srgbClr val="33444F"/>
-                </a:solidFill>
-                <a:latin typeface="Calibri" pitchFamily="34" charset="0"/>
-                <a:ea typeface="Calibri" pitchFamily="34" charset="-122"/>
-                <a:cs typeface="Calibri" pitchFamily="34" charset="-120"/>
-              </a:rPr>
-              <a:t>These are concentrated intracellularly; red-cell lysis releases them, producing concordant spurious elevations.</a:t>
-            </a:r>
-            <a:endParaRPr lang="en-US" sz="1250" dirty="0"/>
           </a:p>
         </p:txBody>
       </p:sp>
@@ -11507,9 +11387,9 @@
               <a:buNone/>
             </a:pPr>
             <a:r>
-              <a:rPr lang="en-US" sz="1350" b="1" dirty="0">
-                <a:solidFill>
-                  <a:srgbClr val="0D4A92"/>
+              <a:rPr lang="en-US" sz="1350" b="0" dirty="0">
+                <a:solidFill>
+                  <a:srgbClr val="33444F"/>
                 </a:solidFill>
                 <a:latin typeface="Calibri" pitchFamily="34" charset="0"/>
                 <a:ea typeface="Calibri" pitchFamily="34" charset="-122"/>
@@ -11578,130 +11458,6 @@
               <a:t>E. Clerical error</a:t>
             </a:r>
             <a:endParaRPr lang="en-US" sz="1350" dirty="0"/>
-          </a:p>
-        </p:txBody>
-      </p:sp>
-      <p:sp>
-        <p:nvSpPr>
-          <p:cNvPr id="6" name="Shape 4"/>
-          <p:cNvSpPr/>
-          <p:nvPr/>
-        </p:nvSpPr>
-        <p:spPr>
-          <a:xfrm>
-            <a:off x="7201632" y="2395728"/>
-            <a:ext cx="4423136" cy="3246120"/>
-          </a:xfrm>
-          <a:prstGeom prst="roundRect">
-            <a:avLst>
-              <a:gd name="adj" fmla="val 2535"/>
-            </a:avLst>
-          </a:prstGeom>
-          <a:solidFill>
-            <a:srgbClr val="E7EFFA"/>
-          </a:solidFill>
-          <a:ln/>
-          <a:effectLst>
-            <a:outerShdw sx="100000" sy="100000" kx="0" ky="0" algn="bl" rotWithShape="0" blurRad="88900" dist="25400" dir="5400000">
-              <a:srgbClr val="22303C">
-                <a:alpha val="12000"/>
-              </a:srgbClr>
-            </a:outerShdw>
-          </a:effectLst>
-        </p:spPr>
-      </p:sp>
-      <p:sp>
-        <p:nvSpPr>
-          <p:cNvPr id="7" name="Text 5"/>
-          <p:cNvSpPr/>
-          <p:nvPr/>
-        </p:nvSpPr>
-        <p:spPr>
-          <a:xfrm>
-            <a:off x="7439376" y="2578608"/>
-            <a:ext cx="3965936" cy="457200"/>
-          </a:xfrm>
-          <a:prstGeom prst="rect">
-            <a:avLst/>
-          </a:prstGeom>
-          <a:noFill/>
-          <a:ln/>
-        </p:spPr>
-        <p:txBody>
-          <a:bodyPr wrap="square" lIns="0" tIns="0" rIns="0" bIns="0" rtlCol="0" anchor="ctr"/>
-          <a:lstStyle/>
-          <a:p>
-            <a:pPr indent="0" marL="0">
-              <a:buNone/>
-            </a:pPr>
-            <a:r>
-              <a:rPr lang="en-US" sz="1500" b="1" dirty="0">
-                <a:solidFill>
-                  <a:srgbClr val="1565C0"/>
-                </a:solidFill>
-                <a:latin typeface="Calibri" pitchFamily="34" charset="0"/>
-                <a:ea typeface="Calibri" pitchFamily="34" charset="-122"/>
-                <a:cs typeface="Calibri" pitchFamily="34" charset="-120"/>
-              </a:rPr>
-              <a:t>ANSWER  </a:t>
-            </a:r>
-            <a:pPr indent="0" marL="0">
-              <a:buNone/>
-            </a:pPr>
-            <a:r>
-              <a:rPr lang="en-US" sz="1500" b="1" dirty="0">
-                <a:solidFill>
-                  <a:srgbClr val="1B2A38"/>
-                </a:solidFill>
-                <a:latin typeface="Calibri" pitchFamily="34" charset="0"/>
-                <a:ea typeface="Calibri" pitchFamily="34" charset="-122"/>
-                <a:cs typeface="Calibri" pitchFamily="34" charset="-120"/>
-              </a:rPr>
-              <a:t>B — A trend (systematic error)</a:t>
-            </a:r>
-            <a:endParaRPr lang="en-US" sz="1500" dirty="0"/>
-          </a:p>
-        </p:txBody>
-      </p:sp>
-      <p:sp>
-        <p:nvSpPr>
-          <p:cNvPr id="8" name="Text 6"/>
-          <p:cNvSpPr/>
-          <p:nvPr/>
-        </p:nvSpPr>
-        <p:spPr>
-          <a:xfrm>
-            <a:off x="7439376" y="3127248"/>
-            <a:ext cx="3947648" cy="2377440"/>
-          </a:xfrm>
-          <a:prstGeom prst="rect">
-            <a:avLst/>
-          </a:prstGeom>
-          <a:noFill/>
-          <a:ln/>
-        </p:spPr>
-        <p:txBody>
-          <a:bodyPr wrap="square" lIns="0" tIns="0" rIns="0" bIns="0" rtlCol="0" anchor="t"/>
-          <a:lstStyle/>
-          <a:p>
-            <a:pPr algn="l" indent="0" marL="0">
-              <a:lnSpc>
-                <a:spcPct val="108000"/>
-              </a:lnSpc>
-              <a:buNone/>
-            </a:pPr>
-            <a:r>
-              <a:rPr lang="en-US" sz="1250" dirty="0">
-                <a:solidFill>
-                  <a:srgbClr val="33444F"/>
-                </a:solidFill>
-                <a:latin typeface="Calibri" pitchFamily="34" charset="0"/>
-                <a:ea typeface="Calibri" pitchFamily="34" charset="-122"/>
-                <a:cs typeface="Calibri" pitchFamily="34" charset="-120"/>
-              </a:rPr>
-              <a:t>A gradual, progressive drift is a trend (systematic error). An abrupt step would be a shift (new lot/calibration).</a:t>
-            </a:r>
-            <a:endParaRPr lang="en-US" sz="1250" dirty="0"/>
           </a:p>
         </p:txBody>
       </p:sp>
@@ -12011,9 +11767,9 @@
               <a:buNone/>
             </a:pPr>
             <a:r>
-              <a:rPr lang="en-US" sz="1350" b="1" dirty="0">
-                <a:solidFill>
-                  <a:srgbClr val="0D4A92"/>
+              <a:rPr lang="en-US" sz="1350" b="0" dirty="0">
+                <a:solidFill>
+                  <a:srgbClr val="33444F"/>
                 </a:solidFill>
                 <a:latin typeface="Calibri" pitchFamily="34" charset="0"/>
                 <a:ea typeface="Calibri" pitchFamily="34" charset="-122"/>
@@ -12082,130 +11838,6 @@
               <a:t>E. Biotin interference</a:t>
             </a:r>
             <a:endParaRPr lang="en-US" sz="1350" dirty="0"/>
-          </a:p>
-        </p:txBody>
-      </p:sp>
-      <p:sp>
-        <p:nvSpPr>
-          <p:cNvPr id="6" name="Shape 4"/>
-          <p:cNvSpPr/>
-          <p:nvPr/>
-        </p:nvSpPr>
-        <p:spPr>
-          <a:xfrm>
-            <a:off x="7201632" y="2395728"/>
-            <a:ext cx="4423136" cy="3246120"/>
-          </a:xfrm>
-          <a:prstGeom prst="roundRect">
-            <a:avLst>
-              <a:gd name="adj" fmla="val 2535"/>
-            </a:avLst>
-          </a:prstGeom>
-          <a:solidFill>
-            <a:srgbClr val="E7EFFA"/>
-          </a:solidFill>
-          <a:ln/>
-          <a:effectLst>
-            <a:outerShdw sx="100000" sy="100000" kx="0" ky="0" algn="bl" rotWithShape="0" blurRad="88900" dist="25400" dir="5400000">
-              <a:srgbClr val="22303C">
-                <a:alpha val="12000"/>
-              </a:srgbClr>
-            </a:outerShdw>
-          </a:effectLst>
-        </p:spPr>
-      </p:sp>
-      <p:sp>
-        <p:nvSpPr>
-          <p:cNvPr id="7" name="Text 5"/>
-          <p:cNvSpPr/>
-          <p:nvPr/>
-        </p:nvSpPr>
-        <p:spPr>
-          <a:xfrm>
-            <a:off x="7439376" y="2578608"/>
-            <a:ext cx="3965936" cy="457200"/>
-          </a:xfrm>
-          <a:prstGeom prst="rect">
-            <a:avLst/>
-          </a:prstGeom>
-          <a:noFill/>
-          <a:ln/>
-        </p:spPr>
-        <p:txBody>
-          <a:bodyPr wrap="square" lIns="0" tIns="0" rIns="0" bIns="0" rtlCol="0" anchor="ctr"/>
-          <a:lstStyle/>
-          <a:p>
-            <a:pPr indent="0" marL="0">
-              <a:buNone/>
-            </a:pPr>
-            <a:r>
-              <a:rPr lang="en-US" sz="1500" b="1" dirty="0">
-                <a:solidFill>
-                  <a:srgbClr val="1565C0"/>
-                </a:solidFill>
-                <a:latin typeface="Calibri" pitchFamily="34" charset="0"/>
-                <a:ea typeface="Calibri" pitchFamily="34" charset="-122"/>
-                <a:cs typeface="Calibri" pitchFamily="34" charset="-120"/>
-              </a:rPr>
-              <a:t>ANSWER  </a:t>
-            </a:r>
-            <a:pPr indent="0" marL="0">
-              <a:buNone/>
-            </a:pPr>
-            <a:r>
-              <a:rPr lang="en-US" sz="1500" b="1" dirty="0">
-                <a:solidFill>
-                  <a:srgbClr val="1B2A38"/>
-                </a:solidFill>
-                <a:latin typeface="Calibri" pitchFamily="34" charset="0"/>
-                <a:ea typeface="Calibri" pitchFamily="34" charset="-122"/>
-                <a:cs typeface="Calibri" pitchFamily="34" charset="-120"/>
-              </a:rPr>
-              <a:t>B — Macro-CK</a:t>
-            </a:r>
-            <a:endParaRPr lang="en-US" sz="1500" dirty="0"/>
-          </a:p>
-        </p:txBody>
-      </p:sp>
-      <p:sp>
-        <p:nvSpPr>
-          <p:cNvPr id="8" name="Text 6"/>
-          <p:cNvSpPr/>
-          <p:nvPr/>
-        </p:nvSpPr>
-        <p:spPr>
-          <a:xfrm>
-            <a:off x="7439376" y="3127248"/>
-            <a:ext cx="3947648" cy="2377440"/>
-          </a:xfrm>
-          <a:prstGeom prst="rect">
-            <a:avLst/>
-          </a:prstGeom>
-          <a:noFill/>
-          <a:ln/>
-        </p:spPr>
-        <p:txBody>
-          <a:bodyPr wrap="square" lIns="0" tIns="0" rIns="0" bIns="0" rtlCol="0" anchor="t"/>
-          <a:lstStyle/>
-          <a:p>
-            <a:pPr algn="l" indent="0" marL="0">
-              <a:lnSpc>
-                <a:spcPct val="108000"/>
-              </a:lnSpc>
-              <a:buNone/>
-            </a:pPr>
-            <a:r>
-              <a:rPr lang="en-US" sz="1250" dirty="0">
-                <a:solidFill>
-                  <a:srgbClr val="33444F"/>
-                </a:solidFill>
-                <a:latin typeface="Calibri" pitchFamily="34" charset="0"/>
-                <a:ea typeface="Calibri" pitchFamily="34" charset="-122"/>
-                <a:cs typeface="Calibri" pitchFamily="34" charset="-120"/>
-              </a:rPr>
-              <a:t>Macro-analytes (macro-CK, macroprolactin) are immunoglobulin-bound forms causing persistent, clinically silent elevations; confirm with special handling/PEG.</a:t>
-            </a:r>
-            <a:endParaRPr lang="en-US" sz="1250" dirty="0"/>
           </a:p>
         </p:txBody>
       </p:sp>
@@ -12446,6 +12078,10 @@
           </a:solidFill>
           <a:ln/>
         </p:spPr>
+        <p:txBody>
+          <a:bodyPr/>
+          <a:p/>
+        </p:txBody>
       </p:sp>
       <p:sp>
         <p:nvSpPr>
@@ -12473,6 +12109,10 @@
             </a:outerShdw>
           </a:effectLst>
         </p:spPr>
+        <p:txBody>
+          <a:bodyPr/>
+          <a:p/>
+        </p:txBody>
       </p:sp>
       <p:sp>
         <p:nvSpPr>
@@ -12573,6 +12213,10 @@
           </a:solidFill>
           <a:ln/>
         </p:spPr>
+        <p:txBody>
+          <a:bodyPr/>
+          <a:p/>
+        </p:txBody>
       </p:sp>
       <p:sp>
         <p:nvSpPr>
@@ -12600,6 +12244,10 @@
             </a:outerShdw>
           </a:effectLst>
         </p:spPr>
+        <p:txBody>
+          <a:bodyPr/>
+          <a:p/>
+        </p:txBody>
       </p:sp>
       <p:sp>
         <p:nvSpPr>
@@ -12700,6 +12348,10 @@
           </a:solidFill>
           <a:ln/>
         </p:spPr>
+        <p:txBody>
+          <a:bodyPr/>
+          <a:p/>
+        </p:txBody>
       </p:sp>
       <p:sp>
         <p:nvSpPr>
@@ -12727,6 +12379,10 @@
             </a:outerShdw>
           </a:effectLst>
         </p:spPr>
+        <p:txBody>
+          <a:bodyPr/>
+          <a:p/>
+        </p:txBody>
       </p:sp>
       <p:sp>
         <p:nvSpPr>
@@ -12827,6 +12483,10 @@
           </a:solidFill>
           <a:ln/>
         </p:spPr>
+        <p:txBody>
+          <a:bodyPr/>
+          <a:p/>
+        </p:txBody>
       </p:sp>
       <p:sp>
         <p:nvSpPr>
@@ -12854,6 +12514,10 @@
             </a:outerShdw>
           </a:effectLst>
         </p:spPr>
+        <p:txBody>
+          <a:bodyPr/>
+          <a:p/>
+        </p:txBody>
       </p:sp>
       <p:sp>
         <p:nvSpPr>
@@ -12954,6 +12618,10 @@
           </a:solidFill>
           <a:ln/>
         </p:spPr>
+        <p:txBody>
+          <a:bodyPr/>
+          <a:p/>
+        </p:txBody>
       </p:sp>
       <p:sp>
         <p:nvSpPr>
@@ -12981,6 +12649,10 @@
             </a:outerShdw>
           </a:effectLst>
         </p:spPr>
+        <p:txBody>
+          <a:bodyPr/>
+          <a:p/>
+        </p:txBody>
       </p:sp>
       <p:sp>
         <p:nvSpPr>
@@ -13464,6 +13136,994 @@
 </p:sld>
 </file>
 
+<file path=ppt/slides/slide28.xml><?xml version="1.0" encoding="utf-8"?>
+<p:sld xmlns:a="http://schemas.openxmlformats.org/drawingml/2006/main" xmlns:p="http://schemas.openxmlformats.org/presentationml/2006/main" xmlns:r="http://schemas.openxmlformats.org/officeDocument/2006/relationships">
+  <p:cSld>
+    <p:spTree>
+      <p:nvGrpSpPr>
+        <p:cNvPr id="1" name=""/>
+        <p:cNvGrpSpPr/>
+        <p:nvPr/>
+      </p:nvGrpSpPr>
+      <p:grpSpPr/>
+      <p:sp>
+        <p:nvSpPr>
+          <p:cNvPr id="2" name="Text 0"/>
+          <p:cNvSpPr/>
+          <p:nvPr/>
+        </p:nvSpPr>
+        <p:spPr>
+          <a:xfrm>
+            <a:off x="566928" y="329184"/>
+            <a:ext cx="10515600" cy="310896"/>
+          </a:xfrm>
+          <a:prstGeom prst="rect">
+            <a:avLst/>
+          </a:prstGeom>
+          <a:noFill/>
+          <a:ln/>
+        </p:spPr>
+        <p:txBody>
+          <a:bodyPr wrap="square" lIns="0" tIns="0" rIns="0" bIns="0" rtlCol="0" anchor="ctr"/>
+          <a:lstStyle/>
+          <a:p>
+            <a:pPr algn="l" indent="0" marL="0">
+              <a:buNone/>
+            </a:pPr>
+            <a:r>
+              <a:rPr lang="en-US" sz="1100" b="1" spc="150" kern="0" dirty="0">
+                <a:solidFill>
+                  <a:srgbClr val="1565C0"/>
+                </a:solidFill>
+                <a:latin typeface="Calibri" pitchFamily="34" charset="0"/>
+                <a:ea typeface="Calibri" pitchFamily="34" charset="-122"/>
+                <a:cs typeface="Calibri" pitchFamily="34" charset="-120"/>
+              </a:rPr>
+              <a:t>CLINICAL CHEMISTRY   ·   BOARD REVIEW  ·  Q4</a:t>
+            </a:r>
+            <a:endParaRPr lang="en-US" sz="1100" dirty="0"/>
+          </a:p>
+        </p:txBody>
+      </p:sp>
+      <p:sp>
+        <p:nvSpPr>
+          <p:cNvPr id="3" name="Text 1"/>
+          <p:cNvSpPr/>
+          <p:nvPr/>
+        </p:nvSpPr>
+        <p:spPr>
+          <a:xfrm>
+            <a:off x="566928" y="713232"/>
+            <a:ext cx="11064240" cy="749808"/>
+          </a:xfrm>
+          <a:prstGeom prst="rect">
+            <a:avLst/>
+          </a:prstGeom>
+          <a:noFill/>
+          <a:ln/>
+        </p:spPr>
+        <p:txBody>
+          <a:bodyPr wrap="square" lIns="0" tIns="0" rIns="0" bIns="0" rtlCol="0" anchor="ctr"/>
+          <a:lstStyle/>
+          <a:p>
+            <a:pPr algn="l" indent="0" marL="0">
+              <a:buNone/>
+            </a:pPr>
+            <a:r>
+              <a:rPr lang="en-US" sz="2600" b="1" dirty="0">
+                <a:solidFill>
+                  <a:srgbClr val="0E3A5F"/>
+                </a:solidFill>
+                <a:latin typeface="Calibri" pitchFamily="34" charset="0"/>
+                <a:ea typeface="Calibri" pitchFamily="34" charset="-122"/>
+                <a:cs typeface="Calibri" pitchFamily="34" charset="-120"/>
+              </a:rPr>
+              <a:t>Board-Style Review</a:t>
+            </a:r>
+            <a:endParaRPr lang="en-US" sz="2600" dirty="0"/>
+          </a:p>
+        </p:txBody>
+      </p:sp>
+      <p:sp>
+        <p:nvSpPr>
+          <p:cNvPr id="4" name="Text 2"/>
+          <p:cNvSpPr/>
+          <p:nvPr/>
+        </p:nvSpPr>
+        <p:spPr>
+          <a:xfrm>
+            <a:off x="566928" y="1417320"/>
+            <a:ext cx="11057839" cy="914400"/>
+          </a:xfrm>
+          <a:prstGeom prst="rect">
+            <a:avLst/>
+          </a:prstGeom>
+          <a:noFill/>
+          <a:ln/>
+        </p:spPr>
+        <p:txBody>
+          <a:bodyPr wrap="square" lIns="0" tIns="0" rIns="0" bIns="0" rtlCol="0" anchor="t"/>
+          <a:lstStyle/>
+          <a:p>
+            <a:pPr algn="l" indent="0" marL="0">
+              <a:lnSpc>
+                <a:spcPct val="105000"/>
+              </a:lnSpc>
+              <a:buNone/>
+            </a:pPr>
+            <a:r>
+              <a:rPr lang="en-US" sz="1450" b="1" dirty="0">
+                <a:solidFill>
+                  <a:srgbClr val="1B2A38"/>
+                </a:solidFill>
+                <a:latin typeface="Calibri" pitchFamily="34" charset="0"/>
+                <a:ea typeface="Calibri" pitchFamily="34" charset="-122"/>
+                <a:cs typeface="Calibri" pitchFamily="34" charset="-120"/>
+              </a:rPr>
+              <a:t>A persistently elevated CK with no clinical correlate and normal other muscle markers most likely reflects:</a:t>
+            </a:r>
+            <a:endParaRPr lang="en-US" sz="1450" dirty="0"/>
+          </a:p>
+        </p:txBody>
+      </p:sp>
+      <p:sp>
+        <p:nvSpPr>
+          <p:cNvPr id="5" name="Text 3"/>
+          <p:cNvSpPr/>
+          <p:nvPr/>
+        </p:nvSpPr>
+        <p:spPr>
+          <a:xfrm>
+            <a:off x="658368" y="2395728"/>
+            <a:ext cx="6192390" cy="3017520"/>
+          </a:xfrm>
+          <a:prstGeom prst="rect">
+            <a:avLst/>
+          </a:prstGeom>
+          <a:noFill/>
+          <a:ln/>
+        </p:spPr>
+        <p:txBody>
+          <a:bodyPr wrap="square" lIns="0" tIns="0" rIns="0" bIns="0" rtlCol="0" anchor="t"/>
+          <a:lstStyle/>
+          <a:p>
+            <a:pPr algn="l" indent="0" marL="0">
+              <a:spcAft>
+                <a:spcPts val="600"/>
+              </a:spcAft>
+              <a:buNone/>
+            </a:pPr>
+            <a:r>
+              <a:rPr lang="en-US" sz="1350" dirty="0">
+                <a:solidFill>
+                  <a:srgbClr val="33444F"/>
+                </a:solidFill>
+                <a:latin typeface="Calibri" pitchFamily="34" charset="0"/>
+                <a:ea typeface="Calibri" pitchFamily="34" charset="-122"/>
+                <a:cs typeface="Calibri" pitchFamily="34" charset="-120"/>
+              </a:rPr>
+              <a:t>A. Acute myocardial infarction</a:t>
+            </a:r>
+            <a:endParaRPr lang="en-US" sz="1350" dirty="0"/>
+          </a:p>
+          <a:p>
+            <a:pPr algn="l" indent="0" marL="0">
+              <a:spcAft>
+                <a:spcPts val="600"/>
+              </a:spcAft>
+              <a:buNone/>
+            </a:pPr>
+            <a:r>
+              <a:rPr lang="en-US" sz="1350" b="1" dirty="0">
+                <a:solidFill>
+                  <a:srgbClr val="0D4A92"/>
+                </a:solidFill>
+                <a:latin typeface="Calibri" pitchFamily="34" charset="0"/>
+                <a:ea typeface="Calibri" pitchFamily="34" charset="-122"/>
+                <a:cs typeface="Calibri" pitchFamily="34" charset="-120"/>
+              </a:rPr>
+              <a:t>B. Macro-CK (immunoglobulin-bound CK)</a:t>
+            </a:r>
+            <a:endParaRPr lang="en-US" sz="1350" dirty="0"/>
+          </a:p>
+          <a:p>
+            <a:pPr algn="l" indent="0" marL="0">
+              <a:spcAft>
+                <a:spcPts val="600"/>
+              </a:spcAft>
+              <a:buNone/>
+            </a:pPr>
+            <a:r>
+              <a:rPr lang="en-US" sz="1350" dirty="0">
+                <a:solidFill>
+                  <a:srgbClr val="33444F"/>
+                </a:solidFill>
+                <a:latin typeface="Calibri" pitchFamily="34" charset="0"/>
+                <a:ea typeface="Calibri" pitchFamily="34" charset="-122"/>
+                <a:cs typeface="Calibri" pitchFamily="34" charset="-120"/>
+              </a:rPr>
+              <a:t>C. Rhabdomyolysis</a:t>
+            </a:r>
+            <a:endParaRPr lang="en-US" sz="1350" dirty="0"/>
+          </a:p>
+          <a:p>
+            <a:pPr algn="l" indent="0" marL="0">
+              <a:spcAft>
+                <a:spcPts val="600"/>
+              </a:spcAft>
+              <a:buNone/>
+            </a:pPr>
+            <a:r>
+              <a:rPr lang="en-US" sz="1350" dirty="0">
+                <a:solidFill>
+                  <a:srgbClr val="33444F"/>
+                </a:solidFill>
+                <a:latin typeface="Calibri" pitchFamily="34" charset="0"/>
+                <a:ea typeface="Calibri" pitchFamily="34" charset="-122"/>
+                <a:cs typeface="Calibri" pitchFamily="34" charset="-120"/>
+              </a:rPr>
+              <a:t>D. Hemolysis</a:t>
+            </a:r>
+            <a:endParaRPr lang="en-US" sz="1350" dirty="0"/>
+          </a:p>
+          <a:p>
+            <a:pPr algn="l" indent="0" marL="0">
+              <a:spcAft>
+                <a:spcPts val="600"/>
+              </a:spcAft>
+              <a:buNone/>
+            </a:pPr>
+            <a:r>
+              <a:rPr lang="en-US" sz="1350" dirty="0">
+                <a:solidFill>
+                  <a:srgbClr val="33444F"/>
+                </a:solidFill>
+                <a:latin typeface="Calibri" pitchFamily="34" charset="0"/>
+                <a:ea typeface="Calibri" pitchFamily="34" charset="-122"/>
+                <a:cs typeface="Calibri" pitchFamily="34" charset="-120"/>
+              </a:rPr>
+              <a:t>E. Biotin interference</a:t>
+            </a:r>
+            <a:endParaRPr lang="en-US" sz="1350" dirty="0"/>
+          </a:p>
+        </p:txBody>
+      </p:sp>
+      <p:sp>
+        <p:nvSpPr>
+          <p:cNvPr id="6" name="Shape 4"/>
+          <p:cNvSpPr/>
+          <p:nvPr/>
+        </p:nvSpPr>
+        <p:spPr>
+          <a:xfrm>
+            <a:off x="7201632" y="2395728"/>
+            <a:ext cx="4423136" cy="3246120"/>
+          </a:xfrm>
+          <a:prstGeom prst="roundRect">
+            <a:avLst>
+              <a:gd name="adj" fmla="val 2535"/>
+            </a:avLst>
+          </a:prstGeom>
+          <a:solidFill>
+            <a:srgbClr val="E7EFFA"/>
+          </a:solidFill>
+          <a:ln/>
+          <a:effectLst>
+            <a:outerShdw sx="100000" sy="100000" kx="0" ky="0" algn="bl" rotWithShape="0" blurRad="88900" dist="25400" dir="5400000">
+              <a:srgbClr val="22303C">
+                <a:alpha val="12000"/>
+              </a:srgbClr>
+            </a:outerShdw>
+          </a:effectLst>
+        </p:spPr>
+        <p:txBody>
+          <a:bodyPr/>
+          <a:p/>
+        </p:txBody>
+      </p:sp>
+      <p:sp>
+        <p:nvSpPr>
+          <p:cNvPr id="7" name="Text 5"/>
+          <p:cNvSpPr/>
+          <p:nvPr/>
+        </p:nvSpPr>
+        <p:spPr>
+          <a:xfrm>
+            <a:off x="7439376" y="2578608"/>
+            <a:ext cx="3965936" cy="457200"/>
+          </a:xfrm>
+          <a:prstGeom prst="rect">
+            <a:avLst/>
+          </a:prstGeom>
+          <a:noFill/>
+          <a:ln/>
+        </p:spPr>
+        <p:txBody>
+          <a:bodyPr wrap="square" lIns="0" tIns="0" rIns="0" bIns="0" rtlCol="0" anchor="ctr"/>
+          <a:lstStyle/>
+          <a:p>
+            <a:pPr indent="0" marL="0">
+              <a:buNone/>
+            </a:pPr>
+            <a:r>
+              <a:rPr lang="en-US" sz="1500" b="1" dirty="0">
+                <a:solidFill>
+                  <a:srgbClr val="1565C0"/>
+                </a:solidFill>
+                <a:latin typeface="Calibri" pitchFamily="34" charset="0"/>
+                <a:ea typeface="Calibri" pitchFamily="34" charset="-122"/>
+                <a:cs typeface="Calibri" pitchFamily="34" charset="-120"/>
+              </a:rPr>
+              <a:t>ANSWER  </a:t>
+            </a:r>
+            <a:pPr indent="0" marL="0">
+              <a:buNone/>
+            </a:pPr>
+            <a:r>
+              <a:rPr lang="en-US" sz="1500" b="1" dirty="0">
+                <a:solidFill>
+                  <a:srgbClr val="1B2A38"/>
+                </a:solidFill>
+                <a:latin typeface="Calibri" pitchFamily="34" charset="0"/>
+                <a:ea typeface="Calibri" pitchFamily="34" charset="-122"/>
+                <a:cs typeface="Calibri" pitchFamily="34" charset="-120"/>
+              </a:rPr>
+              <a:t>B — Macro-CK</a:t>
+            </a:r>
+            <a:endParaRPr lang="en-US" sz="1500" dirty="0"/>
+          </a:p>
+        </p:txBody>
+      </p:sp>
+      <p:sp>
+        <p:nvSpPr>
+          <p:cNvPr id="8" name="Text 6"/>
+          <p:cNvSpPr/>
+          <p:nvPr/>
+        </p:nvSpPr>
+        <p:spPr>
+          <a:xfrm>
+            <a:off x="7439376" y="3127248"/>
+            <a:ext cx="3947648" cy="2377440"/>
+          </a:xfrm>
+          <a:prstGeom prst="rect">
+            <a:avLst/>
+          </a:prstGeom>
+          <a:noFill/>
+          <a:ln/>
+        </p:spPr>
+        <p:txBody>
+          <a:bodyPr wrap="square" lIns="0" tIns="0" rIns="0" bIns="0" rtlCol="0" anchor="t"/>
+          <a:lstStyle/>
+          <a:p>
+            <a:pPr algn="l" indent="0" marL="0">
+              <a:lnSpc>
+                <a:spcPct val="108000"/>
+              </a:lnSpc>
+              <a:buNone/>
+            </a:pPr>
+            <a:r>
+              <a:rPr lang="en-US" sz="1250" dirty="0">
+                <a:solidFill>
+                  <a:srgbClr val="33444F"/>
+                </a:solidFill>
+                <a:latin typeface="Calibri" pitchFamily="34" charset="0"/>
+                <a:ea typeface="Calibri" pitchFamily="34" charset="-122"/>
+                <a:cs typeface="Calibri" pitchFamily="34" charset="-120"/>
+              </a:rPr>
+              <a:t>Macro-analytes (macro-CK, macroprolactin) are immunoglobulin-bound forms causing persistent, clinically silent elevations; confirm with special handling/PEG.</a:t>
+            </a:r>
+            <a:endParaRPr lang="en-US" sz="1250" dirty="0"/>
+          </a:p>
+        </p:txBody>
+      </p:sp>
+      <p:sp>
+        <p:nvSpPr>
+          <p:cNvPr id="9" name="Text 7"/>
+          <p:cNvSpPr/>
+          <p:nvPr/>
+        </p:nvSpPr>
+        <p:spPr>
+          <a:xfrm>
+            <a:off x="566928" y="6473952"/>
+            <a:ext cx="7772400" cy="274320"/>
+          </a:xfrm>
+          <a:prstGeom prst="rect">
+            <a:avLst/>
+          </a:prstGeom>
+          <a:noFill/>
+          <a:ln/>
+        </p:spPr>
+        <p:txBody>
+          <a:bodyPr wrap="square" lIns="0" tIns="0" rIns="0" bIns="0" rtlCol="0" anchor="ctr"/>
+          <a:lstStyle/>
+          <a:p>
+            <a:pPr algn="l" indent="0" marL="0">
+              <a:buNone/>
+            </a:pPr>
+            <a:r>
+              <a:rPr lang="en-US" sz="850" dirty="0">
+                <a:solidFill>
+                  <a:srgbClr val="9AA8B4"/>
+                </a:solidFill>
+                <a:latin typeface="Calibri" pitchFamily="34" charset="0"/>
+                <a:ea typeface="Calibri" pitchFamily="34" charset="-122"/>
+                <a:cs typeface="Calibri" pitchFamily="34" charset="-120"/>
+              </a:rPr>
+              <a:t>Makassed General Hospital  ·  Department of Laboratory Medicine</a:t>
+            </a:r>
+            <a:endParaRPr lang="en-US" sz="850" dirty="0"/>
+          </a:p>
+        </p:txBody>
+      </p:sp>
+      <p:sp>
+        <p:nvSpPr>
+          <p:cNvPr id="10" name="Text 8"/>
+          <p:cNvSpPr/>
+          <p:nvPr/>
+        </p:nvSpPr>
+        <p:spPr>
+          <a:xfrm>
+            <a:off x="9814255" y="6473952"/>
+            <a:ext cx="1828800" cy="274320"/>
+          </a:xfrm>
+          <a:prstGeom prst="rect">
+            <a:avLst/>
+          </a:prstGeom>
+          <a:noFill/>
+          <a:ln/>
+        </p:spPr>
+        <p:txBody>
+          <a:bodyPr wrap="square" lIns="0" tIns="0" rIns="0" bIns="0" rtlCol="0" anchor="ctr"/>
+          <a:lstStyle/>
+          <a:p>
+            <a:pPr algn="r" indent="0" marL="0">
+              <a:buNone/>
+            </a:pPr>
+            <a:r>
+              <a:rPr lang="en-US" sz="850" dirty="0">
+                <a:solidFill>
+                  <a:srgbClr val="9AA8B4"/>
+                </a:solidFill>
+                <a:latin typeface="Calibri" pitchFamily="34" charset="0"/>
+                <a:ea typeface="Calibri" pitchFamily="34" charset="-122"/>
+                <a:cs typeface="Calibri" pitchFamily="34" charset="-120"/>
+              </a:rPr>
+              <a:t>CP Lecture Series</a:t>
+            </a:r>
+            <a:pPr algn="r" indent="0" marL="0">
+              <a:buNone/>
+            </a:pPr>
+            <a:r>
+              <a:rPr lang="en-US" sz="850" dirty="0">
+                <a:solidFill>
+                  <a:srgbClr val="DCE4EC"/>
+                </a:solidFill>
+                <a:latin typeface="Calibri" pitchFamily="34" charset="0"/>
+                <a:ea typeface="Calibri" pitchFamily="34" charset="-122"/>
+                <a:cs typeface="Calibri" pitchFamily="34" charset="-120"/>
+              </a:rPr>
+              <a:t>   ·   </a:t>
+            </a:r>
+            <a:pPr algn="r" indent="0" marL="0">
+              <a:buNone/>
+            </a:pPr>
+            <a:r>
+              <a:rPr lang="en-US" sz="850" b="1" dirty="0">
+                <a:solidFill>
+                  <a:srgbClr val="1565C0"/>
+                </a:solidFill>
+                <a:latin typeface="Calibri" pitchFamily="34" charset="0"/>
+                <a:ea typeface="Calibri" pitchFamily="34" charset="-122"/>
+                <a:cs typeface="Calibri" pitchFamily="34" charset="-120"/>
+              </a:rPr>
+              <a:t>22</a:t>
+            </a:r>
+            <a:endParaRPr lang="en-US" sz="850" dirty="0"/>
+          </a:p>
+        </p:txBody>
+      </p:sp>
+    </p:spTree>
+  </p:cSld>
+  <p:clrMapOvr>
+    <a:masterClrMapping/>
+  </p:clrMapOvr>
+</p:sld>
+</file>
+
+<file path=ppt/slides/slide29.xml><?xml version="1.0" encoding="utf-8"?>
+<p:sld xmlns:a="http://schemas.openxmlformats.org/drawingml/2006/main" xmlns:p="http://schemas.openxmlformats.org/presentationml/2006/main" xmlns:r="http://schemas.openxmlformats.org/officeDocument/2006/relationships">
+  <p:cSld>
+    <p:spTree>
+      <p:nvGrpSpPr>
+        <p:cNvPr id="1" name=""/>
+        <p:cNvGrpSpPr/>
+        <p:nvPr/>
+      </p:nvGrpSpPr>
+      <p:grpSpPr/>
+      <p:sp>
+        <p:nvSpPr>
+          <p:cNvPr id="2" name="Text 0"/>
+          <p:cNvSpPr/>
+          <p:nvPr/>
+        </p:nvSpPr>
+        <p:spPr>
+          <a:xfrm>
+            <a:off x="566928" y="329184"/>
+            <a:ext cx="10515600" cy="310896"/>
+          </a:xfrm>
+          <a:prstGeom prst="rect">
+            <a:avLst/>
+          </a:prstGeom>
+          <a:noFill/>
+          <a:ln/>
+        </p:spPr>
+        <p:txBody>
+          <a:bodyPr wrap="square" lIns="0" tIns="0" rIns="0" bIns="0" rtlCol="0" anchor="ctr"/>
+          <a:lstStyle/>
+          <a:p>
+            <a:pPr algn="l" indent="0" marL="0">
+              <a:buNone/>
+            </a:pPr>
+            <a:r>
+              <a:rPr lang="en-US" sz="1100" b="1" spc="150" kern="0" dirty="0">
+                <a:solidFill>
+                  <a:srgbClr val="1565C0"/>
+                </a:solidFill>
+                <a:latin typeface="Calibri" pitchFamily="34" charset="0"/>
+                <a:ea typeface="Calibri" pitchFamily="34" charset="-122"/>
+                <a:cs typeface="Calibri" pitchFamily="34" charset="-120"/>
+              </a:rPr>
+              <a:t>CLINICAL CHEMISTRY   ·   BOARD REVIEW  ·  Q3</a:t>
+            </a:r>
+            <a:endParaRPr lang="en-US" sz="1100" dirty="0"/>
+          </a:p>
+        </p:txBody>
+      </p:sp>
+      <p:sp>
+        <p:nvSpPr>
+          <p:cNvPr id="3" name="Text 1"/>
+          <p:cNvSpPr/>
+          <p:nvPr/>
+        </p:nvSpPr>
+        <p:spPr>
+          <a:xfrm>
+            <a:off x="566928" y="713232"/>
+            <a:ext cx="11064240" cy="749808"/>
+          </a:xfrm>
+          <a:prstGeom prst="rect">
+            <a:avLst/>
+          </a:prstGeom>
+          <a:noFill/>
+          <a:ln/>
+        </p:spPr>
+        <p:txBody>
+          <a:bodyPr wrap="square" lIns="0" tIns="0" rIns="0" bIns="0" rtlCol="0" anchor="ctr"/>
+          <a:lstStyle/>
+          <a:p>
+            <a:pPr algn="l" indent="0" marL="0">
+              <a:buNone/>
+            </a:pPr>
+            <a:r>
+              <a:rPr lang="en-US" sz="2600" b="1" dirty="0">
+                <a:solidFill>
+                  <a:srgbClr val="0E3A5F"/>
+                </a:solidFill>
+                <a:latin typeface="Calibri" pitchFamily="34" charset="0"/>
+                <a:ea typeface="Calibri" pitchFamily="34" charset="-122"/>
+                <a:cs typeface="Calibri" pitchFamily="34" charset="-120"/>
+              </a:rPr>
+              <a:t>Board-Style Review</a:t>
+            </a:r>
+            <a:endParaRPr lang="en-US" sz="2600" dirty="0"/>
+          </a:p>
+        </p:txBody>
+      </p:sp>
+      <p:sp>
+        <p:nvSpPr>
+          <p:cNvPr id="4" name="Text 2"/>
+          <p:cNvSpPr/>
+          <p:nvPr/>
+        </p:nvSpPr>
+        <p:spPr>
+          <a:xfrm>
+            <a:off x="566928" y="1417320"/>
+            <a:ext cx="11057839" cy="914400"/>
+          </a:xfrm>
+          <a:prstGeom prst="rect">
+            <a:avLst/>
+          </a:prstGeom>
+          <a:noFill/>
+          <a:ln/>
+        </p:spPr>
+        <p:txBody>
+          <a:bodyPr wrap="square" lIns="0" tIns="0" rIns="0" bIns="0" rtlCol="0" anchor="t"/>
+          <a:lstStyle/>
+          <a:p>
+            <a:pPr algn="l" indent="0" marL="0">
+              <a:lnSpc>
+                <a:spcPct val="105000"/>
+              </a:lnSpc>
+              <a:buNone/>
+            </a:pPr>
+            <a:r>
+              <a:rPr lang="en-US" sz="1450" b="1" dirty="0">
+                <a:solidFill>
+                  <a:srgbClr val="1B2A38"/>
+                </a:solidFill>
+                <a:latin typeface="Calibri" pitchFamily="34" charset="0"/>
+                <a:ea typeface="Calibri" pitchFamily="34" charset="-122"/>
+                <a:cs typeface="Calibri" pitchFamily="34" charset="-120"/>
+              </a:rPr>
+              <a:t>On a Levey-Jennings chart, the control mean gradually drifts upward over two weeks. This indicates:</a:t>
+            </a:r>
+            <a:endParaRPr lang="en-US" sz="1450" dirty="0"/>
+          </a:p>
+        </p:txBody>
+      </p:sp>
+      <p:sp>
+        <p:nvSpPr>
+          <p:cNvPr id="5" name="Text 3"/>
+          <p:cNvSpPr/>
+          <p:nvPr/>
+        </p:nvSpPr>
+        <p:spPr>
+          <a:xfrm>
+            <a:off x="658368" y="2395728"/>
+            <a:ext cx="6192390" cy="3017520"/>
+          </a:xfrm>
+          <a:prstGeom prst="rect">
+            <a:avLst/>
+          </a:prstGeom>
+          <a:noFill/>
+          <a:ln/>
+        </p:spPr>
+        <p:txBody>
+          <a:bodyPr wrap="square" lIns="0" tIns="0" rIns="0" bIns="0" rtlCol="0" anchor="t"/>
+          <a:lstStyle/>
+          <a:p>
+            <a:pPr algn="l" indent="0" marL="0">
+              <a:spcAft>
+                <a:spcPts val="600"/>
+              </a:spcAft>
+              <a:buNone/>
+            </a:pPr>
+            <a:r>
+              <a:rPr lang="en-US" sz="1350" dirty="0">
+                <a:solidFill>
+                  <a:srgbClr val="33444F"/>
+                </a:solidFill>
+                <a:latin typeface="Calibri" pitchFamily="34" charset="0"/>
+                <a:ea typeface="Calibri" pitchFamily="34" charset="-122"/>
+                <a:cs typeface="Calibri" pitchFamily="34" charset="-120"/>
+              </a:rPr>
+              <a:t>A. Random error</a:t>
+            </a:r>
+            <a:endParaRPr lang="en-US" sz="1350" dirty="0"/>
+          </a:p>
+          <a:p>
+            <a:pPr algn="l" indent="0" marL="0">
+              <a:spcAft>
+                <a:spcPts val="600"/>
+              </a:spcAft>
+              <a:buNone/>
+            </a:pPr>
+            <a:r>
+              <a:rPr lang="en-US" sz="1350" b="1" dirty="0">
+                <a:solidFill>
+                  <a:srgbClr val="0D4A92"/>
+                </a:solidFill>
+                <a:latin typeface="Calibri" pitchFamily="34" charset="0"/>
+                <a:ea typeface="Calibri" pitchFamily="34" charset="-122"/>
+                <a:cs typeface="Calibri" pitchFamily="34" charset="-120"/>
+              </a:rPr>
+              <a:t>B. A trend (systematic error, e.g., reagent deterioration)</a:t>
+            </a:r>
+            <a:endParaRPr lang="en-US" sz="1350" dirty="0"/>
+          </a:p>
+          <a:p>
+            <a:pPr algn="l" indent="0" marL="0">
+              <a:spcAft>
+                <a:spcPts val="600"/>
+              </a:spcAft>
+              <a:buNone/>
+            </a:pPr>
+            <a:r>
+              <a:rPr lang="en-US" sz="1350" dirty="0">
+                <a:solidFill>
+                  <a:srgbClr val="33444F"/>
+                </a:solidFill>
+                <a:latin typeface="Calibri" pitchFamily="34" charset="0"/>
+                <a:ea typeface="Calibri" pitchFamily="34" charset="-122"/>
+                <a:cs typeface="Calibri" pitchFamily="34" charset="-120"/>
+              </a:rPr>
+              <a:t>C. Normal variation</a:t>
+            </a:r>
+            <a:endParaRPr lang="en-US" sz="1350" dirty="0"/>
+          </a:p>
+          <a:p>
+            <a:pPr algn="l" indent="0" marL="0">
+              <a:spcAft>
+                <a:spcPts val="600"/>
+              </a:spcAft>
+              <a:buNone/>
+            </a:pPr>
+            <a:r>
+              <a:rPr lang="en-US" sz="1350" dirty="0">
+                <a:solidFill>
+                  <a:srgbClr val="33444F"/>
+                </a:solidFill>
+                <a:latin typeface="Calibri" pitchFamily="34" charset="0"/>
+                <a:ea typeface="Calibri" pitchFamily="34" charset="-122"/>
+                <a:cs typeface="Calibri" pitchFamily="34" charset="-120"/>
+              </a:rPr>
+              <a:t>D. A shift from a new lot</a:t>
+            </a:r>
+            <a:endParaRPr lang="en-US" sz="1350" dirty="0"/>
+          </a:p>
+          <a:p>
+            <a:pPr algn="l" indent="0" marL="0">
+              <a:spcAft>
+                <a:spcPts val="600"/>
+              </a:spcAft>
+              <a:buNone/>
+            </a:pPr>
+            <a:r>
+              <a:rPr lang="en-US" sz="1350" dirty="0">
+                <a:solidFill>
+                  <a:srgbClr val="33444F"/>
+                </a:solidFill>
+                <a:latin typeface="Calibri" pitchFamily="34" charset="0"/>
+                <a:ea typeface="Calibri" pitchFamily="34" charset="-122"/>
+                <a:cs typeface="Calibri" pitchFamily="34" charset="-120"/>
+              </a:rPr>
+              <a:t>E. Clerical error</a:t>
+            </a:r>
+            <a:endParaRPr lang="en-US" sz="1350" dirty="0"/>
+          </a:p>
+        </p:txBody>
+      </p:sp>
+      <p:sp>
+        <p:nvSpPr>
+          <p:cNvPr id="6" name="Shape 4"/>
+          <p:cNvSpPr/>
+          <p:nvPr/>
+        </p:nvSpPr>
+        <p:spPr>
+          <a:xfrm>
+            <a:off x="7201632" y="2395728"/>
+            <a:ext cx="4423136" cy="3246120"/>
+          </a:xfrm>
+          <a:prstGeom prst="roundRect">
+            <a:avLst>
+              <a:gd name="adj" fmla="val 2535"/>
+            </a:avLst>
+          </a:prstGeom>
+          <a:solidFill>
+            <a:srgbClr val="E7EFFA"/>
+          </a:solidFill>
+          <a:ln/>
+          <a:effectLst>
+            <a:outerShdw sx="100000" sy="100000" kx="0" ky="0" algn="bl" rotWithShape="0" blurRad="88900" dist="25400" dir="5400000">
+              <a:srgbClr val="22303C">
+                <a:alpha val="12000"/>
+              </a:srgbClr>
+            </a:outerShdw>
+          </a:effectLst>
+        </p:spPr>
+        <p:txBody>
+          <a:bodyPr/>
+          <a:p/>
+        </p:txBody>
+      </p:sp>
+      <p:sp>
+        <p:nvSpPr>
+          <p:cNvPr id="7" name="Text 5"/>
+          <p:cNvSpPr/>
+          <p:nvPr/>
+        </p:nvSpPr>
+        <p:spPr>
+          <a:xfrm>
+            <a:off x="7439376" y="2578608"/>
+            <a:ext cx="3965936" cy="457200"/>
+          </a:xfrm>
+          <a:prstGeom prst="rect">
+            <a:avLst/>
+          </a:prstGeom>
+          <a:noFill/>
+          <a:ln/>
+        </p:spPr>
+        <p:txBody>
+          <a:bodyPr wrap="square" lIns="0" tIns="0" rIns="0" bIns="0" rtlCol="0" anchor="ctr"/>
+          <a:lstStyle/>
+          <a:p>
+            <a:pPr indent="0" marL="0">
+              <a:buNone/>
+            </a:pPr>
+            <a:r>
+              <a:rPr lang="en-US" sz="1500" b="1" dirty="0">
+                <a:solidFill>
+                  <a:srgbClr val="1565C0"/>
+                </a:solidFill>
+                <a:latin typeface="Calibri" pitchFamily="34" charset="0"/>
+                <a:ea typeface="Calibri" pitchFamily="34" charset="-122"/>
+                <a:cs typeface="Calibri" pitchFamily="34" charset="-120"/>
+              </a:rPr>
+              <a:t>ANSWER  </a:t>
+            </a:r>
+            <a:pPr indent="0" marL="0">
+              <a:buNone/>
+            </a:pPr>
+            <a:r>
+              <a:rPr lang="en-US" sz="1500" b="1" dirty="0">
+                <a:solidFill>
+                  <a:srgbClr val="1B2A38"/>
+                </a:solidFill>
+                <a:latin typeface="Calibri" pitchFamily="34" charset="0"/>
+                <a:ea typeface="Calibri" pitchFamily="34" charset="-122"/>
+                <a:cs typeface="Calibri" pitchFamily="34" charset="-120"/>
+              </a:rPr>
+              <a:t>B — A trend (systematic error)</a:t>
+            </a:r>
+            <a:endParaRPr lang="en-US" sz="1500" dirty="0"/>
+          </a:p>
+        </p:txBody>
+      </p:sp>
+      <p:sp>
+        <p:nvSpPr>
+          <p:cNvPr id="8" name="Text 6"/>
+          <p:cNvSpPr/>
+          <p:nvPr/>
+        </p:nvSpPr>
+        <p:spPr>
+          <a:xfrm>
+            <a:off x="7439376" y="3127248"/>
+            <a:ext cx="3947648" cy="2377440"/>
+          </a:xfrm>
+          <a:prstGeom prst="rect">
+            <a:avLst/>
+          </a:prstGeom>
+          <a:noFill/>
+          <a:ln/>
+        </p:spPr>
+        <p:txBody>
+          <a:bodyPr wrap="square" lIns="0" tIns="0" rIns="0" bIns="0" rtlCol="0" anchor="t"/>
+          <a:lstStyle/>
+          <a:p>
+            <a:pPr algn="l" indent="0" marL="0">
+              <a:lnSpc>
+                <a:spcPct val="108000"/>
+              </a:lnSpc>
+              <a:buNone/>
+            </a:pPr>
+            <a:r>
+              <a:rPr lang="en-US" sz="1250" dirty="0">
+                <a:solidFill>
+                  <a:srgbClr val="33444F"/>
+                </a:solidFill>
+                <a:latin typeface="Calibri" pitchFamily="34" charset="0"/>
+                <a:ea typeface="Calibri" pitchFamily="34" charset="-122"/>
+                <a:cs typeface="Calibri" pitchFamily="34" charset="-120"/>
+              </a:rPr>
+              <a:t>A gradual, progressive drift is a trend (systematic error). An abrupt step would be a shift (new lot/calibration).</a:t>
+            </a:r>
+            <a:endParaRPr lang="en-US" sz="1250" dirty="0"/>
+          </a:p>
+        </p:txBody>
+      </p:sp>
+      <p:sp>
+        <p:nvSpPr>
+          <p:cNvPr id="9" name="Text 7"/>
+          <p:cNvSpPr/>
+          <p:nvPr/>
+        </p:nvSpPr>
+        <p:spPr>
+          <a:xfrm>
+            <a:off x="566928" y="6473952"/>
+            <a:ext cx="7772400" cy="274320"/>
+          </a:xfrm>
+          <a:prstGeom prst="rect">
+            <a:avLst/>
+          </a:prstGeom>
+          <a:noFill/>
+          <a:ln/>
+        </p:spPr>
+        <p:txBody>
+          <a:bodyPr wrap="square" lIns="0" tIns="0" rIns="0" bIns="0" rtlCol="0" anchor="ctr"/>
+          <a:lstStyle/>
+          <a:p>
+            <a:pPr algn="l" indent="0" marL="0">
+              <a:buNone/>
+            </a:pPr>
+            <a:r>
+              <a:rPr lang="en-US" sz="850" dirty="0">
+                <a:solidFill>
+                  <a:srgbClr val="9AA8B4"/>
+                </a:solidFill>
+                <a:latin typeface="Calibri" pitchFamily="34" charset="0"/>
+                <a:ea typeface="Calibri" pitchFamily="34" charset="-122"/>
+                <a:cs typeface="Calibri" pitchFamily="34" charset="-120"/>
+              </a:rPr>
+              <a:t>Makassed General Hospital  ·  Department of Laboratory Medicine</a:t>
+            </a:r>
+            <a:endParaRPr lang="en-US" sz="850" dirty="0"/>
+          </a:p>
+        </p:txBody>
+      </p:sp>
+      <p:sp>
+        <p:nvSpPr>
+          <p:cNvPr id="10" name="Text 8"/>
+          <p:cNvSpPr/>
+          <p:nvPr/>
+        </p:nvSpPr>
+        <p:spPr>
+          <a:xfrm>
+            <a:off x="9814255" y="6473952"/>
+            <a:ext cx="1828800" cy="274320"/>
+          </a:xfrm>
+          <a:prstGeom prst="rect">
+            <a:avLst/>
+          </a:prstGeom>
+          <a:noFill/>
+          <a:ln/>
+        </p:spPr>
+        <p:txBody>
+          <a:bodyPr wrap="square" lIns="0" tIns="0" rIns="0" bIns="0" rtlCol="0" anchor="ctr"/>
+          <a:lstStyle/>
+          <a:p>
+            <a:pPr algn="r" indent="0" marL="0">
+              <a:buNone/>
+            </a:pPr>
+            <a:r>
+              <a:rPr lang="en-US" sz="850" dirty="0">
+                <a:solidFill>
+                  <a:srgbClr val="9AA8B4"/>
+                </a:solidFill>
+                <a:latin typeface="Calibri" pitchFamily="34" charset="0"/>
+                <a:ea typeface="Calibri" pitchFamily="34" charset="-122"/>
+                <a:cs typeface="Calibri" pitchFamily="34" charset="-120"/>
+              </a:rPr>
+              <a:t>CP Lecture Series</a:t>
+            </a:r>
+            <a:pPr algn="r" indent="0" marL="0">
+              <a:buNone/>
+            </a:pPr>
+            <a:r>
+              <a:rPr lang="en-US" sz="850" dirty="0">
+                <a:solidFill>
+                  <a:srgbClr val="DCE4EC"/>
+                </a:solidFill>
+                <a:latin typeface="Calibri" pitchFamily="34" charset="0"/>
+                <a:ea typeface="Calibri" pitchFamily="34" charset="-122"/>
+                <a:cs typeface="Calibri" pitchFamily="34" charset="-120"/>
+              </a:rPr>
+              <a:t>   ·   </a:t>
+            </a:r>
+            <a:pPr algn="r" indent="0" marL="0">
+              <a:buNone/>
+            </a:pPr>
+            <a:r>
+              <a:rPr lang="en-US" sz="850" b="1" dirty="0">
+                <a:solidFill>
+                  <a:srgbClr val="1565C0"/>
+                </a:solidFill>
+                <a:latin typeface="Calibri" pitchFamily="34" charset="0"/>
+                <a:ea typeface="Calibri" pitchFamily="34" charset="-122"/>
+                <a:cs typeface="Calibri" pitchFamily="34" charset="-120"/>
+              </a:rPr>
+              <a:t>21</a:t>
+            </a:r>
+            <a:endParaRPr lang="en-US" sz="850" dirty="0"/>
+          </a:p>
+        </p:txBody>
+      </p:sp>
+    </p:spTree>
+  </p:cSld>
+  <p:clrMapOvr>
+    <a:masterClrMapping/>
+  </p:clrMapOvr>
+</p:sld>
+</file>
+
 <file path=ppt/slides/slide3.xml><?xml version="1.0" encoding="utf-8"?>
 <p:sld xmlns:a="http://schemas.openxmlformats.org/drawingml/2006/main" xmlns:r="http://schemas.openxmlformats.org/officeDocument/2006/relationships" xmlns:p="http://schemas.openxmlformats.org/presentationml/2006/main">
   <p:cSld name="Slide 3">
@@ -13594,6 +14254,10 @@
             </a:outerShdw>
           </a:effectLst>
         </p:spPr>
+        <p:txBody>
+          <a:bodyPr/>
+          <a:p/>
+        </p:txBody>
       </p:sp>
       <p:sp>
         <p:nvSpPr>
@@ -13621,6 +14285,10 @@
             </a:outerShdw>
           </a:effectLst>
         </p:spPr>
+        <p:txBody>
+          <a:bodyPr/>
+          <a:p/>
+        </p:txBody>
       </p:sp>
       <p:sp>
         <p:nvSpPr>
@@ -13728,6 +14396,10 @@
             </a:outerShdw>
           </a:effectLst>
         </p:spPr>
+        <p:txBody>
+          <a:bodyPr/>
+          <a:p/>
+        </p:txBody>
       </p:sp>
       <p:sp>
         <p:nvSpPr>
@@ -13755,6 +14427,10 @@
             </a:outerShdw>
           </a:effectLst>
         </p:spPr>
+        <p:txBody>
+          <a:bodyPr/>
+          <a:p/>
+        </p:txBody>
       </p:sp>
       <p:sp>
         <p:nvSpPr>
@@ -13862,6 +14538,10 @@
             </a:outerShdw>
           </a:effectLst>
         </p:spPr>
+        <p:txBody>
+          <a:bodyPr/>
+          <a:p/>
+        </p:txBody>
       </p:sp>
       <p:sp>
         <p:nvSpPr>
@@ -13889,6 +14569,10 @@
             </a:outerShdw>
           </a:effectLst>
         </p:spPr>
+        <p:txBody>
+          <a:bodyPr/>
+          <a:p/>
+        </p:txBody>
       </p:sp>
       <p:sp>
         <p:nvSpPr>
@@ -13996,6 +14680,10 @@
             </a:outerShdw>
           </a:effectLst>
         </p:spPr>
+        <p:txBody>
+          <a:bodyPr/>
+          <a:p/>
+        </p:txBody>
       </p:sp>
       <p:sp>
         <p:nvSpPr>
@@ -14023,6 +14711,10 @@
             </a:outerShdw>
           </a:effectLst>
         </p:spPr>
+        <p:txBody>
+          <a:bodyPr/>
+          <a:p/>
+        </p:txBody>
       </p:sp>
       <p:sp>
         <p:nvSpPr>
@@ -14130,6 +14822,10 @@
             </a:outerShdw>
           </a:effectLst>
         </p:spPr>
+        <p:txBody>
+          <a:bodyPr/>
+          <a:p/>
+        </p:txBody>
       </p:sp>
       <p:sp>
         <p:nvSpPr>
@@ -14157,6 +14853,10 @@
             </a:outerShdw>
           </a:effectLst>
         </p:spPr>
+        <p:txBody>
+          <a:bodyPr/>
+          <a:p/>
+        </p:txBody>
       </p:sp>
       <p:sp>
         <p:nvSpPr>
@@ -14264,6 +14964,10 @@
             </a:outerShdw>
           </a:effectLst>
         </p:spPr>
+        <p:txBody>
+          <a:bodyPr/>
+          <a:p/>
+        </p:txBody>
       </p:sp>
       <p:sp>
         <p:nvSpPr>
@@ -14291,6 +14995,10 @@
             </a:outerShdw>
           </a:effectLst>
         </p:spPr>
+        <p:txBody>
+          <a:bodyPr/>
+          <a:p/>
+        </p:txBody>
       </p:sp>
       <p:sp>
         <p:nvSpPr>
@@ -14471,6 +15179,994 @@
                 <a:cs typeface="Calibri" pitchFamily="34" charset="-120"/>
               </a:rPr>
               <a:t>3</a:t>
+            </a:r>
+            <a:endParaRPr lang="en-US" sz="850" dirty="0"/>
+          </a:p>
+        </p:txBody>
+      </p:sp>
+    </p:spTree>
+  </p:cSld>
+  <p:clrMapOvr>
+    <a:masterClrMapping/>
+  </p:clrMapOvr>
+</p:sld>
+</file>
+
+<file path=ppt/slides/slide30.xml><?xml version="1.0" encoding="utf-8"?>
+<p:sld xmlns:a="http://schemas.openxmlformats.org/drawingml/2006/main" xmlns:p="http://schemas.openxmlformats.org/presentationml/2006/main" xmlns:r="http://schemas.openxmlformats.org/officeDocument/2006/relationships">
+  <p:cSld>
+    <p:spTree>
+      <p:nvGrpSpPr>
+        <p:cNvPr id="1" name=""/>
+        <p:cNvGrpSpPr/>
+        <p:nvPr/>
+      </p:nvGrpSpPr>
+      <p:grpSpPr/>
+      <p:sp>
+        <p:nvSpPr>
+          <p:cNvPr id="2" name="Text 0"/>
+          <p:cNvSpPr/>
+          <p:nvPr/>
+        </p:nvSpPr>
+        <p:spPr>
+          <a:xfrm>
+            <a:off x="566928" y="329184"/>
+            <a:ext cx="10515600" cy="310896"/>
+          </a:xfrm>
+          <a:prstGeom prst="rect">
+            <a:avLst/>
+          </a:prstGeom>
+          <a:noFill/>
+          <a:ln/>
+        </p:spPr>
+        <p:txBody>
+          <a:bodyPr wrap="square" lIns="0" tIns="0" rIns="0" bIns="0" rtlCol="0" anchor="ctr"/>
+          <a:lstStyle/>
+          <a:p>
+            <a:pPr algn="l" indent="0" marL="0">
+              <a:buNone/>
+            </a:pPr>
+            <a:r>
+              <a:rPr lang="en-US" sz="1100" b="1" spc="150" kern="0" dirty="0">
+                <a:solidFill>
+                  <a:srgbClr val="1565C0"/>
+                </a:solidFill>
+                <a:latin typeface="Calibri" pitchFamily="34" charset="0"/>
+                <a:ea typeface="Calibri" pitchFamily="34" charset="-122"/>
+                <a:cs typeface="Calibri" pitchFamily="34" charset="-120"/>
+              </a:rPr>
+              <a:t>CLINICAL CHEMISTRY   ·   BOARD REVIEW  ·  Q2</a:t>
+            </a:r>
+            <a:endParaRPr lang="en-US" sz="1100" dirty="0"/>
+          </a:p>
+        </p:txBody>
+      </p:sp>
+      <p:sp>
+        <p:nvSpPr>
+          <p:cNvPr id="3" name="Text 1"/>
+          <p:cNvSpPr/>
+          <p:nvPr/>
+        </p:nvSpPr>
+        <p:spPr>
+          <a:xfrm>
+            <a:off x="566928" y="713232"/>
+            <a:ext cx="11064240" cy="749808"/>
+          </a:xfrm>
+          <a:prstGeom prst="rect">
+            <a:avLst/>
+          </a:prstGeom>
+          <a:noFill/>
+          <a:ln/>
+        </p:spPr>
+        <p:txBody>
+          <a:bodyPr wrap="square" lIns="0" tIns="0" rIns="0" bIns="0" rtlCol="0" anchor="ctr"/>
+          <a:lstStyle/>
+          <a:p>
+            <a:pPr algn="l" indent="0" marL="0">
+              <a:buNone/>
+            </a:pPr>
+            <a:r>
+              <a:rPr lang="en-US" sz="2600" b="1" dirty="0">
+                <a:solidFill>
+                  <a:srgbClr val="0E3A5F"/>
+                </a:solidFill>
+                <a:latin typeface="Calibri" pitchFamily="34" charset="0"/>
+                <a:ea typeface="Calibri" pitchFamily="34" charset="-122"/>
+                <a:cs typeface="Calibri" pitchFamily="34" charset="-120"/>
+              </a:rPr>
+              <a:t>Board-Style Review</a:t>
+            </a:r>
+            <a:endParaRPr lang="en-US" sz="2600" dirty="0"/>
+          </a:p>
+        </p:txBody>
+      </p:sp>
+      <p:sp>
+        <p:nvSpPr>
+          <p:cNvPr id="4" name="Text 2"/>
+          <p:cNvSpPr/>
+          <p:nvPr/>
+        </p:nvSpPr>
+        <p:spPr>
+          <a:xfrm>
+            <a:off x="566928" y="1417320"/>
+            <a:ext cx="11057839" cy="914400"/>
+          </a:xfrm>
+          <a:prstGeom prst="rect">
+            <a:avLst/>
+          </a:prstGeom>
+          <a:noFill/>
+          <a:ln/>
+        </p:spPr>
+        <p:txBody>
+          <a:bodyPr wrap="square" lIns="0" tIns="0" rIns="0" bIns="0" rtlCol="0" anchor="t"/>
+          <a:lstStyle/>
+          <a:p>
+            <a:pPr algn="l" indent="0" marL="0">
+              <a:lnSpc>
+                <a:spcPct val="105000"/>
+              </a:lnSpc>
+              <a:buNone/>
+            </a:pPr>
+            <a:r>
+              <a:rPr lang="en-US" sz="1450" b="1" dirty="0">
+                <a:solidFill>
+                  <a:srgbClr val="1B2A38"/>
+                </a:solidFill>
+                <a:latin typeface="Calibri" pitchFamily="34" charset="0"/>
+                <a:ea typeface="Calibri" pitchFamily="34" charset="-122"/>
+                <a:cs typeface="Calibri" pitchFamily="34" charset="-120"/>
+              </a:rPr>
+              <a:t>Which analytes characteristically rise together due to in vitro hemolysis?</a:t>
+            </a:r>
+            <a:endParaRPr lang="en-US" sz="1450" dirty="0"/>
+          </a:p>
+        </p:txBody>
+      </p:sp>
+      <p:sp>
+        <p:nvSpPr>
+          <p:cNvPr id="5" name="Text 3"/>
+          <p:cNvSpPr/>
+          <p:nvPr/>
+        </p:nvSpPr>
+        <p:spPr>
+          <a:xfrm>
+            <a:off x="658368" y="2395728"/>
+            <a:ext cx="6192390" cy="3017520"/>
+          </a:xfrm>
+          <a:prstGeom prst="rect">
+            <a:avLst/>
+          </a:prstGeom>
+          <a:noFill/>
+          <a:ln/>
+        </p:spPr>
+        <p:txBody>
+          <a:bodyPr wrap="square" lIns="0" tIns="0" rIns="0" bIns="0" rtlCol="0" anchor="t"/>
+          <a:lstStyle/>
+          <a:p>
+            <a:pPr algn="l" indent="0" marL="0">
+              <a:spcAft>
+                <a:spcPts val="600"/>
+              </a:spcAft>
+              <a:buNone/>
+            </a:pPr>
+            <a:r>
+              <a:rPr lang="en-US" sz="1350" dirty="0">
+                <a:solidFill>
+                  <a:srgbClr val="33444F"/>
+                </a:solidFill>
+                <a:latin typeface="Calibri" pitchFamily="34" charset="0"/>
+                <a:ea typeface="Calibri" pitchFamily="34" charset="-122"/>
+                <a:cs typeface="Calibri" pitchFamily="34" charset="-120"/>
+              </a:rPr>
+              <a:t>A. Sodium, chloride, glucose</a:t>
+            </a:r>
+            <a:endParaRPr lang="en-US" sz="1350" dirty="0"/>
+          </a:p>
+          <a:p>
+            <a:pPr algn="l" indent="0" marL="0">
+              <a:spcAft>
+                <a:spcPts val="600"/>
+              </a:spcAft>
+              <a:buNone/>
+            </a:pPr>
+            <a:r>
+              <a:rPr lang="en-US" sz="1350" b="1" dirty="0">
+                <a:solidFill>
+                  <a:srgbClr val="0D4A92"/>
+                </a:solidFill>
+                <a:latin typeface="Calibri" pitchFamily="34" charset="0"/>
+                <a:ea typeface="Calibri" pitchFamily="34" charset="-122"/>
+                <a:cs typeface="Calibri" pitchFamily="34" charset="-120"/>
+              </a:rPr>
+              <a:t>B. Potassium, LDH, AST, phosphate</a:t>
+            </a:r>
+            <a:endParaRPr lang="en-US" sz="1350" dirty="0"/>
+          </a:p>
+          <a:p>
+            <a:pPr algn="l" indent="0" marL="0">
+              <a:spcAft>
+                <a:spcPts val="600"/>
+              </a:spcAft>
+              <a:buNone/>
+            </a:pPr>
+            <a:r>
+              <a:rPr lang="en-US" sz="1350" dirty="0">
+                <a:solidFill>
+                  <a:srgbClr val="33444F"/>
+                </a:solidFill>
+                <a:latin typeface="Calibri" pitchFamily="34" charset="0"/>
+                <a:ea typeface="Calibri" pitchFamily="34" charset="-122"/>
+                <a:cs typeface="Calibri" pitchFamily="34" charset="-120"/>
+              </a:rPr>
+              <a:t>C. Calcium, albumin, ALP</a:t>
+            </a:r>
+            <a:endParaRPr lang="en-US" sz="1350" dirty="0"/>
+          </a:p>
+          <a:p>
+            <a:pPr algn="l" indent="0" marL="0">
+              <a:spcAft>
+                <a:spcPts val="600"/>
+              </a:spcAft>
+              <a:buNone/>
+            </a:pPr>
+            <a:r>
+              <a:rPr lang="en-US" sz="1350" dirty="0">
+                <a:solidFill>
+                  <a:srgbClr val="33444F"/>
+                </a:solidFill>
+                <a:latin typeface="Calibri" pitchFamily="34" charset="0"/>
+                <a:ea typeface="Calibri" pitchFamily="34" charset="-122"/>
+                <a:cs typeface="Calibri" pitchFamily="34" charset="-120"/>
+              </a:rPr>
+              <a:t>D. Bicarbonate, BUN, creatinine</a:t>
+            </a:r>
+            <a:endParaRPr lang="en-US" sz="1350" dirty="0"/>
+          </a:p>
+          <a:p>
+            <a:pPr algn="l" indent="0" marL="0">
+              <a:spcAft>
+                <a:spcPts val="600"/>
+              </a:spcAft>
+              <a:buNone/>
+            </a:pPr>
+            <a:r>
+              <a:rPr lang="en-US" sz="1350" dirty="0">
+                <a:solidFill>
+                  <a:srgbClr val="33444F"/>
+                </a:solidFill>
+                <a:latin typeface="Calibri" pitchFamily="34" charset="0"/>
+                <a:ea typeface="Calibri" pitchFamily="34" charset="-122"/>
+                <a:cs typeface="Calibri" pitchFamily="34" charset="-120"/>
+              </a:rPr>
+              <a:t>E. TSH, free T4</a:t>
+            </a:r>
+            <a:endParaRPr lang="en-US" sz="1350" dirty="0"/>
+          </a:p>
+        </p:txBody>
+      </p:sp>
+      <p:sp>
+        <p:nvSpPr>
+          <p:cNvPr id="6" name="Shape 4"/>
+          <p:cNvSpPr/>
+          <p:nvPr/>
+        </p:nvSpPr>
+        <p:spPr>
+          <a:xfrm>
+            <a:off x="7201632" y="2395728"/>
+            <a:ext cx="4423136" cy="3246120"/>
+          </a:xfrm>
+          <a:prstGeom prst="roundRect">
+            <a:avLst>
+              <a:gd name="adj" fmla="val 2535"/>
+            </a:avLst>
+          </a:prstGeom>
+          <a:solidFill>
+            <a:srgbClr val="E7EFFA"/>
+          </a:solidFill>
+          <a:ln/>
+          <a:effectLst>
+            <a:outerShdw sx="100000" sy="100000" kx="0" ky="0" algn="bl" rotWithShape="0" blurRad="88900" dist="25400" dir="5400000">
+              <a:srgbClr val="22303C">
+                <a:alpha val="12000"/>
+              </a:srgbClr>
+            </a:outerShdw>
+          </a:effectLst>
+        </p:spPr>
+        <p:txBody>
+          <a:bodyPr/>
+          <a:p/>
+        </p:txBody>
+      </p:sp>
+      <p:sp>
+        <p:nvSpPr>
+          <p:cNvPr id="7" name="Text 5"/>
+          <p:cNvSpPr/>
+          <p:nvPr/>
+        </p:nvSpPr>
+        <p:spPr>
+          <a:xfrm>
+            <a:off x="7439376" y="2578608"/>
+            <a:ext cx="3965936" cy="457200"/>
+          </a:xfrm>
+          <a:prstGeom prst="rect">
+            <a:avLst/>
+          </a:prstGeom>
+          <a:noFill/>
+          <a:ln/>
+        </p:spPr>
+        <p:txBody>
+          <a:bodyPr wrap="square" lIns="0" tIns="0" rIns="0" bIns="0" rtlCol="0" anchor="ctr"/>
+          <a:lstStyle/>
+          <a:p>
+            <a:pPr indent="0" marL="0">
+              <a:buNone/>
+            </a:pPr>
+            <a:r>
+              <a:rPr lang="en-US" sz="1500" b="1" dirty="0">
+                <a:solidFill>
+                  <a:srgbClr val="1565C0"/>
+                </a:solidFill>
+                <a:latin typeface="Calibri" pitchFamily="34" charset="0"/>
+                <a:ea typeface="Calibri" pitchFamily="34" charset="-122"/>
+                <a:cs typeface="Calibri" pitchFamily="34" charset="-120"/>
+              </a:rPr>
+              <a:t>ANSWER  </a:t>
+            </a:r>
+            <a:pPr indent="0" marL="0">
+              <a:buNone/>
+            </a:pPr>
+            <a:r>
+              <a:rPr lang="en-US" sz="1500" b="1" dirty="0">
+                <a:solidFill>
+                  <a:srgbClr val="1B2A38"/>
+                </a:solidFill>
+                <a:latin typeface="Calibri" pitchFamily="34" charset="0"/>
+                <a:ea typeface="Calibri" pitchFamily="34" charset="-122"/>
+                <a:cs typeface="Calibri" pitchFamily="34" charset="-120"/>
+              </a:rPr>
+              <a:t>B — Potassium, LDH, AST, phosphate</a:t>
+            </a:r>
+            <a:endParaRPr lang="en-US" sz="1500" dirty="0"/>
+          </a:p>
+        </p:txBody>
+      </p:sp>
+      <p:sp>
+        <p:nvSpPr>
+          <p:cNvPr id="8" name="Text 6"/>
+          <p:cNvSpPr/>
+          <p:nvPr/>
+        </p:nvSpPr>
+        <p:spPr>
+          <a:xfrm>
+            <a:off x="7439376" y="3127248"/>
+            <a:ext cx="3947648" cy="2377440"/>
+          </a:xfrm>
+          <a:prstGeom prst="rect">
+            <a:avLst/>
+          </a:prstGeom>
+          <a:noFill/>
+          <a:ln/>
+        </p:spPr>
+        <p:txBody>
+          <a:bodyPr wrap="square" lIns="0" tIns="0" rIns="0" bIns="0" rtlCol="0" anchor="t"/>
+          <a:lstStyle/>
+          <a:p>
+            <a:pPr algn="l" indent="0" marL="0">
+              <a:lnSpc>
+                <a:spcPct val="108000"/>
+              </a:lnSpc>
+              <a:buNone/>
+            </a:pPr>
+            <a:r>
+              <a:rPr lang="en-US" sz="1250" dirty="0">
+                <a:solidFill>
+                  <a:srgbClr val="33444F"/>
+                </a:solidFill>
+                <a:latin typeface="Calibri" pitchFamily="34" charset="0"/>
+                <a:ea typeface="Calibri" pitchFamily="34" charset="-122"/>
+                <a:cs typeface="Calibri" pitchFamily="34" charset="-120"/>
+              </a:rPr>
+              <a:t>These are concentrated intracellularly; red-cell lysis releases them, producing concordant spurious elevations.</a:t>
+            </a:r>
+            <a:endParaRPr lang="en-US" sz="1250" dirty="0"/>
+          </a:p>
+        </p:txBody>
+      </p:sp>
+      <p:sp>
+        <p:nvSpPr>
+          <p:cNvPr id="9" name="Text 7"/>
+          <p:cNvSpPr/>
+          <p:nvPr/>
+        </p:nvSpPr>
+        <p:spPr>
+          <a:xfrm>
+            <a:off x="566928" y="6473952"/>
+            <a:ext cx="7772400" cy="274320"/>
+          </a:xfrm>
+          <a:prstGeom prst="rect">
+            <a:avLst/>
+          </a:prstGeom>
+          <a:noFill/>
+          <a:ln/>
+        </p:spPr>
+        <p:txBody>
+          <a:bodyPr wrap="square" lIns="0" tIns="0" rIns="0" bIns="0" rtlCol="0" anchor="ctr"/>
+          <a:lstStyle/>
+          <a:p>
+            <a:pPr algn="l" indent="0" marL="0">
+              <a:buNone/>
+            </a:pPr>
+            <a:r>
+              <a:rPr lang="en-US" sz="850" dirty="0">
+                <a:solidFill>
+                  <a:srgbClr val="9AA8B4"/>
+                </a:solidFill>
+                <a:latin typeface="Calibri" pitchFamily="34" charset="0"/>
+                <a:ea typeface="Calibri" pitchFamily="34" charset="-122"/>
+                <a:cs typeface="Calibri" pitchFamily="34" charset="-120"/>
+              </a:rPr>
+              <a:t>Makassed General Hospital  ·  Department of Laboratory Medicine</a:t>
+            </a:r>
+            <a:endParaRPr lang="en-US" sz="850" dirty="0"/>
+          </a:p>
+        </p:txBody>
+      </p:sp>
+      <p:sp>
+        <p:nvSpPr>
+          <p:cNvPr id="10" name="Text 8"/>
+          <p:cNvSpPr/>
+          <p:nvPr/>
+        </p:nvSpPr>
+        <p:spPr>
+          <a:xfrm>
+            <a:off x="9814255" y="6473952"/>
+            <a:ext cx="1828800" cy="274320"/>
+          </a:xfrm>
+          <a:prstGeom prst="rect">
+            <a:avLst/>
+          </a:prstGeom>
+          <a:noFill/>
+          <a:ln/>
+        </p:spPr>
+        <p:txBody>
+          <a:bodyPr wrap="square" lIns="0" tIns="0" rIns="0" bIns="0" rtlCol="0" anchor="ctr"/>
+          <a:lstStyle/>
+          <a:p>
+            <a:pPr algn="r" indent="0" marL="0">
+              <a:buNone/>
+            </a:pPr>
+            <a:r>
+              <a:rPr lang="en-US" sz="850" dirty="0">
+                <a:solidFill>
+                  <a:srgbClr val="9AA8B4"/>
+                </a:solidFill>
+                <a:latin typeface="Calibri" pitchFamily="34" charset="0"/>
+                <a:ea typeface="Calibri" pitchFamily="34" charset="-122"/>
+                <a:cs typeface="Calibri" pitchFamily="34" charset="-120"/>
+              </a:rPr>
+              <a:t>CP Lecture Series</a:t>
+            </a:r>
+            <a:pPr algn="r" indent="0" marL="0">
+              <a:buNone/>
+            </a:pPr>
+            <a:r>
+              <a:rPr lang="en-US" sz="850" dirty="0">
+                <a:solidFill>
+                  <a:srgbClr val="DCE4EC"/>
+                </a:solidFill>
+                <a:latin typeface="Calibri" pitchFamily="34" charset="0"/>
+                <a:ea typeface="Calibri" pitchFamily="34" charset="-122"/>
+                <a:cs typeface="Calibri" pitchFamily="34" charset="-120"/>
+              </a:rPr>
+              <a:t>   ·   </a:t>
+            </a:r>
+            <a:pPr algn="r" indent="0" marL="0">
+              <a:buNone/>
+            </a:pPr>
+            <a:r>
+              <a:rPr lang="en-US" sz="850" b="1" dirty="0">
+                <a:solidFill>
+                  <a:srgbClr val="1565C0"/>
+                </a:solidFill>
+                <a:latin typeface="Calibri" pitchFamily="34" charset="0"/>
+                <a:ea typeface="Calibri" pitchFamily="34" charset="-122"/>
+                <a:cs typeface="Calibri" pitchFamily="34" charset="-120"/>
+              </a:rPr>
+              <a:t>20</a:t>
+            </a:r>
+            <a:endParaRPr lang="en-US" sz="850" dirty="0"/>
+          </a:p>
+        </p:txBody>
+      </p:sp>
+    </p:spTree>
+  </p:cSld>
+  <p:clrMapOvr>
+    <a:masterClrMapping/>
+  </p:clrMapOvr>
+</p:sld>
+</file>
+
+<file path=ppt/slides/slide31.xml><?xml version="1.0" encoding="utf-8"?>
+<p:sld xmlns:a="http://schemas.openxmlformats.org/drawingml/2006/main" xmlns:p="http://schemas.openxmlformats.org/presentationml/2006/main" xmlns:r="http://schemas.openxmlformats.org/officeDocument/2006/relationships">
+  <p:cSld>
+    <p:spTree>
+      <p:nvGrpSpPr>
+        <p:cNvPr id="1" name=""/>
+        <p:cNvGrpSpPr/>
+        <p:nvPr/>
+      </p:nvGrpSpPr>
+      <p:grpSpPr/>
+      <p:sp>
+        <p:nvSpPr>
+          <p:cNvPr id="2" name="Text 0"/>
+          <p:cNvSpPr/>
+          <p:nvPr/>
+        </p:nvSpPr>
+        <p:spPr>
+          <a:xfrm>
+            <a:off x="566928" y="329184"/>
+            <a:ext cx="10515600" cy="310896"/>
+          </a:xfrm>
+          <a:prstGeom prst="rect">
+            <a:avLst/>
+          </a:prstGeom>
+          <a:noFill/>
+          <a:ln/>
+        </p:spPr>
+        <p:txBody>
+          <a:bodyPr wrap="square" lIns="0" tIns="0" rIns="0" bIns="0" rtlCol="0" anchor="ctr"/>
+          <a:lstStyle/>
+          <a:p>
+            <a:pPr algn="l" indent="0" marL="0">
+              <a:buNone/>
+            </a:pPr>
+            <a:r>
+              <a:rPr lang="en-US" sz="1100" b="1" spc="150" kern="0" dirty="0">
+                <a:solidFill>
+                  <a:srgbClr val="1565C0"/>
+                </a:solidFill>
+                <a:latin typeface="Calibri" pitchFamily="34" charset="0"/>
+                <a:ea typeface="Calibri" pitchFamily="34" charset="-122"/>
+                <a:cs typeface="Calibri" pitchFamily="34" charset="-120"/>
+              </a:rPr>
+              <a:t>CLINICAL CHEMISTRY   ·   BOARD REVIEW  ·  Q1</a:t>
+            </a:r>
+            <a:endParaRPr lang="en-US" sz="1100" dirty="0"/>
+          </a:p>
+        </p:txBody>
+      </p:sp>
+      <p:sp>
+        <p:nvSpPr>
+          <p:cNvPr id="3" name="Text 1"/>
+          <p:cNvSpPr/>
+          <p:nvPr/>
+        </p:nvSpPr>
+        <p:spPr>
+          <a:xfrm>
+            <a:off x="566928" y="713232"/>
+            <a:ext cx="11064240" cy="749808"/>
+          </a:xfrm>
+          <a:prstGeom prst="rect">
+            <a:avLst/>
+          </a:prstGeom>
+          <a:noFill/>
+          <a:ln/>
+        </p:spPr>
+        <p:txBody>
+          <a:bodyPr wrap="square" lIns="0" tIns="0" rIns="0" bIns="0" rtlCol="0" anchor="ctr"/>
+          <a:lstStyle/>
+          <a:p>
+            <a:pPr algn="l" indent="0" marL="0">
+              <a:buNone/>
+            </a:pPr>
+            <a:r>
+              <a:rPr lang="en-US" sz="2600" b="1" dirty="0">
+                <a:solidFill>
+                  <a:srgbClr val="0E3A5F"/>
+                </a:solidFill>
+                <a:latin typeface="Calibri" pitchFamily="34" charset="0"/>
+                <a:ea typeface="Calibri" pitchFamily="34" charset="-122"/>
+                <a:cs typeface="Calibri" pitchFamily="34" charset="-120"/>
+              </a:rPr>
+              <a:t>Board-Style Review</a:t>
+            </a:r>
+            <a:endParaRPr lang="en-US" sz="2600" dirty="0"/>
+          </a:p>
+        </p:txBody>
+      </p:sp>
+      <p:sp>
+        <p:nvSpPr>
+          <p:cNvPr id="4" name="Text 2"/>
+          <p:cNvSpPr/>
+          <p:nvPr/>
+        </p:nvSpPr>
+        <p:spPr>
+          <a:xfrm>
+            <a:off x="566928" y="1417320"/>
+            <a:ext cx="11057839" cy="914400"/>
+          </a:xfrm>
+          <a:prstGeom prst="rect">
+            <a:avLst/>
+          </a:prstGeom>
+          <a:noFill/>
+          <a:ln/>
+        </p:spPr>
+        <p:txBody>
+          <a:bodyPr wrap="square" lIns="0" tIns="0" rIns="0" bIns="0" rtlCol="0" anchor="t"/>
+          <a:lstStyle/>
+          <a:p>
+            <a:pPr algn="l" indent="0" marL="0">
+              <a:lnSpc>
+                <a:spcPct val="105000"/>
+              </a:lnSpc>
+              <a:buNone/>
+            </a:pPr>
+            <a:r>
+              <a:rPr lang="en-US" sz="1450" b="1" dirty="0">
+                <a:solidFill>
+                  <a:srgbClr val="1B2A38"/>
+                </a:solidFill>
+                <a:latin typeface="Calibri" pitchFamily="34" charset="0"/>
+                <a:ea typeface="Calibri" pitchFamily="34" charset="-122"/>
+                <a:cs typeface="Calibri" pitchFamily="34" charset="-120"/>
+              </a:rPr>
+              <a:t>A sandwich immunoassay reports an unexpectedly LOW value in a patient you suspect has very high analyte. Best next step?</a:t>
+            </a:r>
+            <a:endParaRPr lang="en-US" sz="1450" dirty="0"/>
+          </a:p>
+        </p:txBody>
+      </p:sp>
+      <p:sp>
+        <p:nvSpPr>
+          <p:cNvPr id="5" name="Text 3"/>
+          <p:cNvSpPr/>
+          <p:nvPr/>
+        </p:nvSpPr>
+        <p:spPr>
+          <a:xfrm>
+            <a:off x="658368" y="2395728"/>
+            <a:ext cx="6192390" cy="3017520"/>
+          </a:xfrm>
+          <a:prstGeom prst="rect">
+            <a:avLst/>
+          </a:prstGeom>
+          <a:noFill/>
+          <a:ln/>
+        </p:spPr>
+        <p:txBody>
+          <a:bodyPr wrap="square" lIns="0" tIns="0" rIns="0" bIns="0" rtlCol="0" anchor="t"/>
+          <a:lstStyle/>
+          <a:p>
+            <a:pPr algn="l" indent="0" marL="0">
+              <a:spcAft>
+                <a:spcPts val="600"/>
+              </a:spcAft>
+              <a:buNone/>
+            </a:pPr>
+            <a:r>
+              <a:rPr lang="en-US" sz="1350" dirty="0">
+                <a:solidFill>
+                  <a:srgbClr val="33444F"/>
+                </a:solidFill>
+                <a:latin typeface="Calibri" pitchFamily="34" charset="0"/>
+                <a:ea typeface="Calibri" pitchFamily="34" charset="-122"/>
+                <a:cs typeface="Calibri" pitchFamily="34" charset="-120"/>
+              </a:rPr>
+              <a:t>A. Report the low value</a:t>
+            </a:r>
+            <a:endParaRPr lang="en-US" sz="1350" dirty="0"/>
+          </a:p>
+          <a:p>
+            <a:pPr algn="l" indent="0" marL="0">
+              <a:spcAft>
+                <a:spcPts val="600"/>
+              </a:spcAft>
+              <a:buNone/>
+            </a:pPr>
+            <a:r>
+              <a:rPr lang="en-US" sz="1350" b="1" dirty="0">
+                <a:solidFill>
+                  <a:srgbClr val="0D4A92"/>
+                </a:solidFill>
+                <a:latin typeface="Calibri" pitchFamily="34" charset="0"/>
+                <a:ea typeface="Calibri" pitchFamily="34" charset="-122"/>
+                <a:cs typeface="Calibri" pitchFamily="34" charset="-120"/>
+              </a:rPr>
+              <a:t>B. Dilute the sample and re-assay (suspect hook effect)</a:t>
+            </a:r>
+            <a:endParaRPr lang="en-US" sz="1350" dirty="0"/>
+          </a:p>
+          <a:p>
+            <a:pPr algn="l" indent="0" marL="0">
+              <a:spcAft>
+                <a:spcPts val="600"/>
+              </a:spcAft>
+              <a:buNone/>
+            </a:pPr>
+            <a:r>
+              <a:rPr lang="en-US" sz="1350" dirty="0">
+                <a:solidFill>
+                  <a:srgbClr val="33444F"/>
+                </a:solidFill>
+                <a:latin typeface="Calibri" pitchFamily="34" charset="0"/>
+                <a:ea typeface="Calibri" pitchFamily="34" charset="-122"/>
+                <a:cs typeface="Calibri" pitchFamily="34" charset="-120"/>
+              </a:rPr>
+              <a:t>C. Add more conjugate</a:t>
+            </a:r>
+            <a:endParaRPr lang="en-US" sz="1350" dirty="0"/>
+          </a:p>
+          <a:p>
+            <a:pPr algn="l" indent="0" marL="0">
+              <a:spcAft>
+                <a:spcPts val="600"/>
+              </a:spcAft>
+              <a:buNone/>
+            </a:pPr>
+            <a:r>
+              <a:rPr lang="en-US" sz="1350" dirty="0">
+                <a:solidFill>
+                  <a:srgbClr val="33444F"/>
+                </a:solidFill>
+                <a:latin typeface="Calibri" pitchFamily="34" charset="0"/>
+                <a:ea typeface="Calibri" pitchFamily="34" charset="-122"/>
+                <a:cs typeface="Calibri" pitchFamily="34" charset="-120"/>
+              </a:rPr>
+              <a:t>D. Switch to a competitive assay only</a:t>
+            </a:r>
+            <a:endParaRPr lang="en-US" sz="1350" dirty="0"/>
+          </a:p>
+          <a:p>
+            <a:pPr algn="l" indent="0" marL="0">
+              <a:spcAft>
+                <a:spcPts val="600"/>
+              </a:spcAft>
+              <a:buNone/>
+            </a:pPr>
+            <a:r>
+              <a:rPr lang="en-US" sz="1350" dirty="0">
+                <a:solidFill>
+                  <a:srgbClr val="33444F"/>
+                </a:solidFill>
+                <a:latin typeface="Calibri" pitchFamily="34" charset="0"/>
+                <a:ea typeface="Calibri" pitchFamily="34" charset="-122"/>
+                <a:cs typeface="Calibri" pitchFamily="34" charset="-120"/>
+              </a:rPr>
+              <a:t>E. Repeat without changes</a:t>
+            </a:r>
+            <a:endParaRPr lang="en-US" sz="1350" dirty="0"/>
+          </a:p>
+        </p:txBody>
+      </p:sp>
+      <p:sp>
+        <p:nvSpPr>
+          <p:cNvPr id="6" name="Shape 4"/>
+          <p:cNvSpPr/>
+          <p:nvPr/>
+        </p:nvSpPr>
+        <p:spPr>
+          <a:xfrm>
+            <a:off x="7201632" y="2395728"/>
+            <a:ext cx="4423136" cy="3246120"/>
+          </a:xfrm>
+          <a:prstGeom prst="roundRect">
+            <a:avLst>
+              <a:gd name="adj" fmla="val 2535"/>
+            </a:avLst>
+          </a:prstGeom>
+          <a:solidFill>
+            <a:srgbClr val="E7EFFA"/>
+          </a:solidFill>
+          <a:ln/>
+          <a:effectLst>
+            <a:outerShdw sx="100000" sy="100000" kx="0" ky="0" algn="bl" rotWithShape="0" blurRad="88900" dist="25400" dir="5400000">
+              <a:srgbClr val="22303C">
+                <a:alpha val="12000"/>
+              </a:srgbClr>
+            </a:outerShdw>
+          </a:effectLst>
+        </p:spPr>
+        <p:txBody>
+          <a:bodyPr/>
+          <a:p/>
+        </p:txBody>
+      </p:sp>
+      <p:sp>
+        <p:nvSpPr>
+          <p:cNvPr id="7" name="Text 5"/>
+          <p:cNvSpPr/>
+          <p:nvPr/>
+        </p:nvSpPr>
+        <p:spPr>
+          <a:xfrm>
+            <a:off x="7439376" y="2578608"/>
+            <a:ext cx="3965936" cy="457200"/>
+          </a:xfrm>
+          <a:prstGeom prst="rect">
+            <a:avLst/>
+          </a:prstGeom>
+          <a:noFill/>
+          <a:ln/>
+        </p:spPr>
+        <p:txBody>
+          <a:bodyPr wrap="square" lIns="0" tIns="0" rIns="0" bIns="0" rtlCol="0" anchor="ctr"/>
+          <a:lstStyle/>
+          <a:p>
+            <a:pPr indent="0" marL="0">
+              <a:buNone/>
+            </a:pPr>
+            <a:r>
+              <a:rPr lang="en-US" sz="1500" b="1" dirty="0">
+                <a:solidFill>
+                  <a:srgbClr val="1565C0"/>
+                </a:solidFill>
+                <a:latin typeface="Calibri" pitchFamily="34" charset="0"/>
+                <a:ea typeface="Calibri" pitchFamily="34" charset="-122"/>
+                <a:cs typeface="Calibri" pitchFamily="34" charset="-120"/>
+              </a:rPr>
+              <a:t>ANSWER  </a:t>
+            </a:r>
+            <a:pPr indent="0" marL="0">
+              <a:buNone/>
+            </a:pPr>
+            <a:r>
+              <a:rPr lang="en-US" sz="1500" b="1" dirty="0">
+                <a:solidFill>
+                  <a:srgbClr val="1B2A38"/>
+                </a:solidFill>
+                <a:latin typeface="Calibri" pitchFamily="34" charset="0"/>
+                <a:ea typeface="Calibri" pitchFamily="34" charset="-122"/>
+                <a:cs typeface="Calibri" pitchFamily="34" charset="-120"/>
+              </a:rPr>
+              <a:t>B — Dilute and re-assay (hook effect)</a:t>
+            </a:r>
+            <a:endParaRPr lang="en-US" sz="1500" dirty="0"/>
+          </a:p>
+        </p:txBody>
+      </p:sp>
+      <p:sp>
+        <p:nvSpPr>
+          <p:cNvPr id="8" name="Text 6"/>
+          <p:cNvSpPr/>
+          <p:nvPr/>
+        </p:nvSpPr>
+        <p:spPr>
+          <a:xfrm>
+            <a:off x="7439376" y="3127248"/>
+            <a:ext cx="3947648" cy="2377440"/>
+          </a:xfrm>
+          <a:prstGeom prst="rect">
+            <a:avLst/>
+          </a:prstGeom>
+          <a:noFill/>
+          <a:ln/>
+        </p:spPr>
+        <p:txBody>
+          <a:bodyPr wrap="square" lIns="0" tIns="0" rIns="0" bIns="0" rtlCol="0" anchor="t"/>
+          <a:lstStyle/>
+          <a:p>
+            <a:pPr algn="l" indent="0" marL="0">
+              <a:lnSpc>
+                <a:spcPct val="108000"/>
+              </a:lnSpc>
+              <a:buNone/>
+            </a:pPr>
+            <a:r>
+              <a:rPr lang="en-US" sz="1250" dirty="0">
+                <a:solidFill>
+                  <a:srgbClr val="33444F"/>
+                </a:solidFill>
+                <a:latin typeface="Calibri" pitchFamily="34" charset="0"/>
+                <a:ea typeface="Calibri" pitchFamily="34" charset="-122"/>
+                <a:cs typeface="Calibri" pitchFamily="34" charset="-120"/>
+              </a:rPr>
+              <a:t>Extremely high analyte saturates a sandwich assay’s antibodies and lowers signal (hook). Dilution relieves saturation and yields the true value.</a:t>
+            </a:r>
+            <a:endParaRPr lang="en-US" sz="1250" dirty="0"/>
+          </a:p>
+        </p:txBody>
+      </p:sp>
+      <p:sp>
+        <p:nvSpPr>
+          <p:cNvPr id="9" name="Text 7"/>
+          <p:cNvSpPr/>
+          <p:nvPr/>
+        </p:nvSpPr>
+        <p:spPr>
+          <a:xfrm>
+            <a:off x="566928" y="6473952"/>
+            <a:ext cx="7772400" cy="274320"/>
+          </a:xfrm>
+          <a:prstGeom prst="rect">
+            <a:avLst/>
+          </a:prstGeom>
+          <a:noFill/>
+          <a:ln/>
+        </p:spPr>
+        <p:txBody>
+          <a:bodyPr wrap="square" lIns="0" tIns="0" rIns="0" bIns="0" rtlCol="0" anchor="ctr"/>
+          <a:lstStyle/>
+          <a:p>
+            <a:pPr algn="l" indent="0" marL="0">
+              <a:buNone/>
+            </a:pPr>
+            <a:r>
+              <a:rPr lang="en-US" sz="850" dirty="0">
+                <a:solidFill>
+                  <a:srgbClr val="9AA8B4"/>
+                </a:solidFill>
+                <a:latin typeface="Calibri" pitchFamily="34" charset="0"/>
+                <a:ea typeface="Calibri" pitchFamily="34" charset="-122"/>
+                <a:cs typeface="Calibri" pitchFamily="34" charset="-120"/>
+              </a:rPr>
+              <a:t>Makassed General Hospital  ·  Department of Laboratory Medicine</a:t>
+            </a:r>
+            <a:endParaRPr lang="en-US" sz="850" dirty="0"/>
+          </a:p>
+        </p:txBody>
+      </p:sp>
+      <p:sp>
+        <p:nvSpPr>
+          <p:cNvPr id="10" name="Text 8"/>
+          <p:cNvSpPr/>
+          <p:nvPr/>
+        </p:nvSpPr>
+        <p:spPr>
+          <a:xfrm>
+            <a:off x="9814255" y="6473952"/>
+            <a:ext cx="1828800" cy="274320"/>
+          </a:xfrm>
+          <a:prstGeom prst="rect">
+            <a:avLst/>
+          </a:prstGeom>
+          <a:noFill/>
+          <a:ln/>
+        </p:spPr>
+        <p:txBody>
+          <a:bodyPr wrap="square" lIns="0" tIns="0" rIns="0" bIns="0" rtlCol="0" anchor="ctr"/>
+          <a:lstStyle/>
+          <a:p>
+            <a:pPr algn="r" indent="0" marL="0">
+              <a:buNone/>
+            </a:pPr>
+            <a:r>
+              <a:rPr lang="en-US" sz="850" dirty="0">
+                <a:solidFill>
+                  <a:srgbClr val="9AA8B4"/>
+                </a:solidFill>
+                <a:latin typeface="Calibri" pitchFamily="34" charset="0"/>
+                <a:ea typeface="Calibri" pitchFamily="34" charset="-122"/>
+                <a:cs typeface="Calibri" pitchFamily="34" charset="-120"/>
+              </a:rPr>
+              <a:t>CP Lecture Series</a:t>
+            </a:r>
+            <a:pPr algn="r" indent="0" marL="0">
+              <a:buNone/>
+            </a:pPr>
+            <a:r>
+              <a:rPr lang="en-US" sz="850" dirty="0">
+                <a:solidFill>
+                  <a:srgbClr val="DCE4EC"/>
+                </a:solidFill>
+                <a:latin typeface="Calibri" pitchFamily="34" charset="0"/>
+                <a:ea typeface="Calibri" pitchFamily="34" charset="-122"/>
+                <a:cs typeface="Calibri" pitchFamily="34" charset="-120"/>
+              </a:rPr>
+              <a:t>   ·   </a:t>
+            </a:r>
+            <a:pPr algn="r" indent="0" marL="0">
+              <a:buNone/>
+            </a:pPr>
+            <a:r>
+              <a:rPr lang="en-US" sz="850" b="1" dirty="0">
+                <a:solidFill>
+                  <a:srgbClr val="1565C0"/>
+                </a:solidFill>
+                <a:latin typeface="Calibri" pitchFamily="34" charset="0"/>
+                <a:ea typeface="Calibri" pitchFamily="34" charset="-122"/>
+                <a:cs typeface="Calibri" pitchFamily="34" charset="-120"/>
+              </a:rPr>
+              <a:t>19</a:t>
             </a:r>
             <a:endParaRPr lang="en-US" sz="850" dirty="0"/>
           </a:p>
@@ -14614,6 +16310,10 @@
             </a:outerShdw>
           </a:effectLst>
         </p:spPr>
+        <p:txBody>
+          <a:bodyPr/>
+          <a:p/>
+        </p:txBody>
       </p:sp>
       <p:sp>
         <p:nvSpPr>
@@ -14641,6 +16341,10 @@
             </a:outerShdw>
           </a:effectLst>
         </p:spPr>
+        <p:txBody>
+          <a:bodyPr/>
+          <a:p/>
+        </p:txBody>
       </p:sp>
       <p:sp>
         <p:nvSpPr>
@@ -14755,6 +16459,10 @@
           </a:solidFill>
           <a:ln/>
         </p:spPr>
+        <p:txBody>
+          <a:bodyPr/>
+          <a:p/>
+        </p:txBody>
       </p:sp>
       <p:sp>
         <p:nvSpPr>
@@ -14782,6 +16490,10 @@
             </a:outerShdw>
           </a:effectLst>
         </p:spPr>
+        <p:txBody>
+          <a:bodyPr/>
+          <a:p/>
+        </p:txBody>
       </p:sp>
       <p:sp>
         <p:nvSpPr>
@@ -14903,6 +16615,10 @@
             </a:outerShdw>
           </a:effectLst>
         </p:spPr>
+        <p:txBody>
+          <a:bodyPr/>
+          <a:p/>
+        </p:txBody>
       </p:sp>
       <p:sp>
         <p:nvSpPr>
@@ -14930,6 +16646,10 @@
             </a:outerShdw>
           </a:effectLst>
         </p:spPr>
+        <p:txBody>
+          <a:bodyPr/>
+          <a:p/>
+        </p:txBody>
       </p:sp>
       <p:sp>
         <p:nvSpPr>
@@ -15044,6 +16764,10 @@
           </a:solidFill>
           <a:ln/>
         </p:spPr>
+        <p:txBody>
+          <a:bodyPr/>
+          <a:p/>
+        </p:txBody>
       </p:sp>
       <p:sp>
         <p:nvSpPr>
@@ -15071,6 +16795,10 @@
             </a:outerShdw>
           </a:effectLst>
         </p:spPr>
+        <p:txBody>
+          <a:bodyPr/>
+          <a:p/>
+        </p:txBody>
       </p:sp>
       <p:sp>
         <p:nvSpPr>
@@ -15192,6 +16920,10 @@
             </a:outerShdw>
           </a:effectLst>
         </p:spPr>
+        <p:txBody>
+          <a:bodyPr/>
+          <a:p/>
+        </p:txBody>
       </p:sp>
       <p:sp>
         <p:nvSpPr>
@@ -15219,6 +16951,10 @@
             </a:outerShdw>
           </a:effectLst>
         </p:spPr>
+        <p:txBody>
+          <a:bodyPr/>
+          <a:p/>
+        </p:txBody>
       </p:sp>
       <p:sp>
         <p:nvSpPr>
@@ -15333,6 +17069,10 @@
           </a:solidFill>
           <a:ln/>
         </p:spPr>
+        <p:txBody>
+          <a:bodyPr/>
+          <a:p/>
+        </p:txBody>
       </p:sp>
       <p:sp>
         <p:nvSpPr>
@@ -15360,6 +17100,10 @@
             </a:outerShdw>
           </a:effectLst>
         </p:spPr>
+        <p:txBody>
+          <a:bodyPr/>
+          <a:p/>
+        </p:txBody>
       </p:sp>
       <p:sp>
         <p:nvSpPr>
@@ -15598,6 +17342,10 @@
           </a:solidFill>
           <a:ln/>
         </p:spPr>
+        <p:txBody>
+          <a:bodyPr/>
+          <a:p/>
+        </p:txBody>
       </p:sp>
       <p:sp>
         <p:nvSpPr>
@@ -15620,6 +17368,10 @@
           </a:solidFill>
           <a:ln/>
         </p:spPr>
+        <p:txBody>
+          <a:bodyPr/>
+          <a:p/>
+        </p:txBody>
       </p:sp>
       <p:sp>
         <p:nvSpPr>
@@ -15876,6 +17628,10 @@
             </a:outerShdw>
           </a:effectLst>
         </p:spPr>
+        <p:txBody>
+          <a:bodyPr/>
+          <a:p/>
+        </p:txBody>
       </p:sp>
       <p:sp>
         <p:nvSpPr>
@@ -16050,6 +17806,10 @@
             </a:outerShdw>
           </a:effectLst>
         </p:spPr>
+        <p:txBody>
+          <a:bodyPr/>
+          <a:p/>
+        </p:txBody>
       </p:sp>
       <p:sp>
         <p:nvSpPr>
@@ -16445,6 +18205,10 @@
             </a:outerShdw>
           </a:effectLst>
         </p:spPr>
+        <p:txBody>
+          <a:bodyPr/>
+          <a:p/>
+        </p:txBody>
       </p:sp>
       <p:pic>
         <p:nvPicPr>
@@ -16753,6 +18517,10 @@
             </a:outerShdw>
           </a:effectLst>
         </p:spPr>
+        <p:txBody>
+          <a:bodyPr/>
+          <a:p/>
+        </p:txBody>
       </p:sp>
       <p:sp>
         <p:nvSpPr>
@@ -16927,6 +18695,10 @@
             </a:outerShdw>
           </a:effectLst>
         </p:spPr>
+        <p:txBody>
+          <a:bodyPr/>
+          <a:p/>
+        </p:txBody>
       </p:sp>
       <p:sp>
         <p:nvSpPr>
@@ -17317,6 +19089,10 @@
             </a:outerShdw>
           </a:effectLst>
         </p:spPr>
+        <p:txBody>
+          <a:bodyPr/>
+          <a:p/>
+        </p:txBody>
       </p:sp>
       <p:sp>
         <p:nvSpPr>
@@ -17491,6 +19267,10 @@
             </a:outerShdw>
           </a:effectLst>
         </p:spPr>
+        <p:txBody>
+          <a:bodyPr/>
+          <a:p/>
+        </p:txBody>
       </p:sp>
       <p:sp>
         <p:nvSpPr>

</xml_diff>